<commit_message>
checkpoint: slide 009 re-certification (annotation rebuild + OMML + deck page 9) + fleet state before slide 049 parenthesis fix
</commit_message>
<xml_diff>
--- a/videos/machine-learning/03_ridger_regression_gradient_descent/recreated_pptx/slide_003_recreated.pptx
+++ b/videos/machine-learning/03_ridger_regression_gradient_descent/recreated_pptx/slide_003_recreated.pptx
@@ -1075,7 +1075,35 @@
                 <a:ea typeface="Arial" pitchFamily="34" charset="-122"/>
                 <a:cs typeface="Arial" pitchFamily="34" charset="-120"/>
               </a:rPr>
-              <a:t> Notation for Linear Regression and Classification (N- Samples)</a:t>
+              <a:t> Notation for Linear Regression and Classification </a:t>
+            </a:r>
+            <a:pPr algn="ctr" indent="0" marL="0">
+              <a:buNone/>
+            </a:pPr>
+            <a:r>
+              <a:rPr lang="en-US" sz="2300" b="1" dirty="0">
+                <a:solidFill>
+                  <a:srgbClr val="0000FF"/>
+                </a:solidFill>
+                <a:latin typeface="Arial" pitchFamily="34" charset="0"/>
+                <a:ea typeface="Arial" pitchFamily="34" charset="-122"/>
+                <a:cs typeface="Arial" pitchFamily="34" charset="-120"/>
+              </a:rPr>
+              <a:t>(N-</a:t>
+            </a:r>
+            <a:pPr algn="ctr" indent="0" marL="0">
+              <a:buNone/>
+            </a:pPr>
+            <a:r>
+              <a:rPr lang="en-US" sz="2300" b="1" dirty="0">
+                <a:solidFill>
+                  <a:srgbClr val="FF0000"/>
+                </a:solidFill>
+                <a:latin typeface="Arial" pitchFamily="34" charset="0"/>
+                <a:ea typeface="Arial" pitchFamily="34" charset="-122"/>
+                <a:cs typeface="Arial" pitchFamily="34" charset="-120"/>
+              </a:rPr>
+              <a:t> Samples)</a:t>
             </a:r>
             <a:endParaRPr lang="en-US" sz="2300" dirty="0"/>
           </a:p>
@@ -1200,7 +1228,7 @@
             <a:avLst/>
           </a:prstGeom>
           <a:solidFill>
-            <a:srgbClr val="FFC0CB"/>
+            <a:srgbClr val="F0A0F0"/>
           </a:solidFill>
           <a:ln/>
         </p:spPr>
@@ -1958,16 +1986,160 @@
           </a:p>
         </p:txBody>
       </p:sp>
-      <p:sp>
-        <p:nvSpPr>
-          <p:cNvPr id="29" name="Shape 27"/>
-          <p:cNvSpPr/>
-          <p:nvPr/>
-        </p:nvSpPr>
-        <p:spPr>
-          <a:xfrm>
-            <a:off x="4210050" y="1968500"/>
-            <a:ext cx="0" cy="1320800"/>
+      <p:pic>
+        <p:nvPicPr>
+          <p:cNvPr id="29" name="Image 0" descr="/home/ahmed/Projects/ai_llm_slides/videos/machine-learning/03_ridger_regression_gradient_descent/recreated_pptx/qa/slide003/parens/col1_L.png">    </p:cNvPr>
+          <p:cNvPicPr>
+            <a:picLocks noChangeAspect="1"/>
+          </p:cNvPicPr>
+          <p:nvPr/>
+        </p:nvPicPr>
+        <p:blipFill>
+          <a:blip r:embed="rId1"/>
+          <a:stretch>
+            <a:fillRect/>
+          </a:stretch>
+        </p:blipFill>
+        <p:spPr>
+          <a:xfrm>
+            <a:off x="3761740" y="1854200"/>
+            <a:ext cx="48260" cy="1485900"/>
+          </a:xfrm>
+          <a:prstGeom prst="rect">
+            <a:avLst/>
+          </a:prstGeom>
+        </p:spPr>
+      </p:pic>
+      <p:pic>
+        <p:nvPicPr>
+          <p:cNvPr id="30" name="Image 1" descr="/home/ahmed/Projects/ai_llm_slides/videos/machine-learning/03_ridger_regression_gradient_descent/recreated_pptx/qa/slide003/parens/col1_R.png">    </p:cNvPr>
+          <p:cNvPicPr>
+            <a:picLocks noChangeAspect="1"/>
+          </p:cNvPicPr>
+          <p:nvPr/>
+        </p:nvPicPr>
+        <p:blipFill>
+          <a:blip r:embed="rId2"/>
+          <a:stretch>
+            <a:fillRect/>
+          </a:stretch>
+        </p:blipFill>
+        <p:spPr>
+          <a:xfrm>
+            <a:off x="4165092" y="1854200"/>
+            <a:ext cx="48260" cy="1485900"/>
+          </a:xfrm>
+          <a:prstGeom prst="rect">
+            <a:avLst/>
+          </a:prstGeom>
+        </p:spPr>
+      </p:pic>
+      <p:pic>
+        <p:nvPicPr>
+          <p:cNvPr id="31" name="Image 2" descr="/home/ahmed/Projects/ai_llm_slides/videos/machine-learning/03_ridger_regression_gradient_descent/recreated_pptx/qa/slide003/parens/col2_L.png">    </p:cNvPr>
+          <p:cNvPicPr>
+            <a:picLocks noChangeAspect="1"/>
+          </p:cNvPicPr>
+          <p:nvPr/>
+        </p:nvPicPr>
+        <p:blipFill>
+          <a:blip r:embed="rId3"/>
+          <a:stretch>
+            <a:fillRect/>
+          </a:stretch>
+        </p:blipFill>
+        <p:spPr>
+          <a:xfrm>
+            <a:off x="4739640" y="1854200"/>
+            <a:ext cx="48260" cy="1485900"/>
+          </a:xfrm>
+          <a:prstGeom prst="rect">
+            <a:avLst/>
+          </a:prstGeom>
+        </p:spPr>
+      </p:pic>
+      <p:pic>
+        <p:nvPicPr>
+          <p:cNvPr id="32" name="Image 3" descr="/home/ahmed/Projects/ai_llm_slides/videos/machine-learning/03_ridger_regression_gradient_descent/recreated_pptx/qa/slide003/parens/col2_R.png">    </p:cNvPr>
+          <p:cNvPicPr>
+            <a:picLocks noChangeAspect="1"/>
+          </p:cNvPicPr>
+          <p:nvPr/>
+        </p:nvPicPr>
+        <p:blipFill>
+          <a:blip r:embed="rId4"/>
+          <a:stretch>
+            <a:fillRect/>
+          </a:stretch>
+        </p:blipFill>
+        <p:spPr>
+          <a:xfrm>
+            <a:off x="5149342" y="1854200"/>
+            <a:ext cx="48260" cy="1485900"/>
+          </a:xfrm>
+          <a:prstGeom prst="rect">
+            <a:avLst/>
+          </a:prstGeom>
+        </p:spPr>
+      </p:pic>
+      <p:pic>
+        <p:nvPicPr>
+          <p:cNvPr id="33" name="Image 4" descr="/home/ahmed/Projects/ai_llm_slides/videos/machine-learning/03_ridger_regression_gradient_descent/recreated_pptx/qa/slide003/parens/col4_L.png">    </p:cNvPr>
+          <p:cNvPicPr>
+            <a:picLocks noChangeAspect="1"/>
+          </p:cNvPicPr>
+          <p:nvPr/>
+        </p:nvPicPr>
+        <p:blipFill>
+          <a:blip r:embed="rId5"/>
+          <a:stretch>
+            <a:fillRect/>
+          </a:stretch>
+        </p:blipFill>
+        <p:spPr>
+          <a:xfrm>
+            <a:off x="6568440" y="1854200"/>
+            <a:ext cx="48260" cy="1485900"/>
+          </a:xfrm>
+          <a:prstGeom prst="rect">
+            <a:avLst/>
+          </a:prstGeom>
+        </p:spPr>
+      </p:pic>
+      <p:pic>
+        <p:nvPicPr>
+          <p:cNvPr id="34" name="Image 5" descr="/home/ahmed/Projects/ai_llm_slides/videos/machine-learning/03_ridger_regression_gradient_descent/recreated_pptx/qa/slide003/parens/col4_R.png">    </p:cNvPr>
+          <p:cNvPicPr>
+            <a:picLocks noChangeAspect="1"/>
+          </p:cNvPicPr>
+          <p:nvPr/>
+        </p:nvPicPr>
+        <p:blipFill>
+          <a:blip r:embed="rId6"/>
+          <a:stretch>
+            <a:fillRect/>
+          </a:stretch>
+        </p:blipFill>
+        <p:spPr>
+          <a:xfrm>
+            <a:off x="6971792" y="1854200"/>
+            <a:ext cx="48260" cy="1485900"/>
+          </a:xfrm>
+          <a:prstGeom prst="rect">
+            <a:avLst/>
+          </a:prstGeom>
+        </p:spPr>
+      </p:pic>
+      <p:sp>
+        <p:nvSpPr>
+          <p:cNvPr id="35" name="Shape 27"/>
+          <p:cNvSpPr/>
+          <p:nvPr/>
+        </p:nvSpPr>
+        <p:spPr>
+          <a:xfrm>
+            <a:off x="3454400" y="3778250"/>
+            <a:ext cx="4102100" cy="0"/>
           </a:xfrm>
           <a:prstGeom prst="line">
             <a:avLst/>
@@ -1983,76 +2155,7 @@
       </p:sp>
       <p:sp>
         <p:nvSpPr>
-          <p:cNvPr id="30" name="Shape 28"/>
-          <p:cNvSpPr/>
-          <p:nvPr/>
-        </p:nvSpPr>
-        <p:spPr>
-          <a:xfrm>
-            <a:off x="5264150" y="1968500"/>
-            <a:ext cx="0" cy="1320800"/>
-          </a:xfrm>
-          <a:prstGeom prst="line">
-            <a:avLst/>
-          </a:prstGeom>
-          <a:noFill/>
-          <a:ln w="12700">
-            <a:solidFill>
-              <a:srgbClr val="000000"/>
-            </a:solidFill>
-            <a:prstDash val="solid"/>
-          </a:ln>
-        </p:spPr>
-      </p:sp>
-      <p:sp>
-        <p:nvSpPr>
-          <p:cNvPr id="31" name="Shape 29"/>
-          <p:cNvSpPr/>
-          <p:nvPr/>
-        </p:nvSpPr>
-        <p:spPr>
-          <a:xfrm>
-            <a:off x="7067550" y="1968500"/>
-            <a:ext cx="0" cy="1320800"/>
-          </a:xfrm>
-          <a:prstGeom prst="line">
-            <a:avLst/>
-          </a:prstGeom>
-          <a:noFill/>
-          <a:ln w="12700">
-            <a:solidFill>
-              <a:srgbClr val="000000"/>
-            </a:solidFill>
-            <a:prstDash val="solid"/>
-          </a:ln>
-        </p:spPr>
-      </p:sp>
-      <p:sp>
-        <p:nvSpPr>
-          <p:cNvPr id="32" name="Shape 30"/>
-          <p:cNvSpPr/>
-          <p:nvPr/>
-        </p:nvSpPr>
-        <p:spPr>
-          <a:xfrm>
-            <a:off x="3454400" y="3778250"/>
-            <a:ext cx="4102100" cy="0"/>
-          </a:xfrm>
-          <a:prstGeom prst="line">
-            <a:avLst/>
-          </a:prstGeom>
-          <a:noFill/>
-          <a:ln w="12700">
-            <a:solidFill>
-              <a:srgbClr val="000000"/>
-            </a:solidFill>
-            <a:prstDash val="solid"/>
-          </a:ln>
-        </p:spPr>
-      </p:sp>
-      <p:sp>
-        <p:nvSpPr>
-          <p:cNvPr id="33" name="Text 31"/>
+          <p:cNvPr id="36" name="Text 28"/>
           <p:cNvSpPr/>
           <p:nvPr/>
         </p:nvSpPr>
@@ -2105,7 +2208,7 @@
       </p:sp>
       <p:sp>
         <p:nvSpPr>
-          <p:cNvPr id="34" name="Text 32"/>
+          <p:cNvPr id="37" name="Text 29"/>
           <p:cNvSpPr/>
           <p:nvPr/>
         </p:nvSpPr>
@@ -2158,7 +2261,7 @@
       </p:sp>
       <p:sp>
         <p:nvSpPr>
-          <p:cNvPr id="35" name="Text 33"/>
+          <p:cNvPr id="38" name="Text 30"/>
           <p:cNvSpPr/>
           <p:nvPr/>
         </p:nvSpPr>
@@ -2211,7 +2314,46 @@
       </p:sp>
       <p:sp>
         <p:nvSpPr>
-          <p:cNvPr id="36" name="Text 34"/>
+          <p:cNvPr id="39" name="Text 31"/>
+          <p:cNvSpPr/>
+          <p:nvPr/>
+        </p:nvSpPr>
+        <p:spPr>
+          <a:xfrm>
+            <a:off x="5867400" y="3530600"/>
+            <a:ext cx="304800" cy="203200"/>
+          </a:xfrm>
+          <a:prstGeom prst="rect">
+            <a:avLst/>
+          </a:prstGeom>
+          <a:noFill/>
+          <a:ln/>
+        </p:spPr>
+        <p:txBody>
+          <a:bodyPr wrap="square" lIns="0" tIns="0" rIns="0" bIns="0" rtlCol="0" anchor="ctr"/>
+          <a:lstStyle/>
+          <a:p>
+            <a:pPr algn="ctr" indent="0" marL="0">
+              <a:buNone/>
+            </a:pPr>
+            <a:r>
+              <a:rPr lang="en-US" sz="1100" i="1" dirty="0">
+                <a:solidFill>
+                  <a:srgbClr val="FF0000"/>
+                </a:solidFill>
+                <a:latin typeface="Arial" pitchFamily="34" charset="0"/>
+                <a:ea typeface="Arial" pitchFamily="34" charset="-122"/>
+                <a:cs typeface="Arial" pitchFamily="34" charset="-120"/>
+              </a:rPr>
+              <a:t>...</a:t>
+            </a:r>
+            <a:endParaRPr lang="en-US" sz="1100" dirty="0"/>
+          </a:p>
+        </p:txBody>
+      </p:sp>
+      <p:sp>
+        <p:nvSpPr>
+          <p:cNvPr id="40" name="Text 32"/>
           <p:cNvSpPr/>
           <p:nvPr/>
         </p:nvSpPr>
@@ -2248,32 +2390,80 @@
           </a:p>
         </p:txBody>
       </p:sp>
-      <p:sp>
-        <p:nvSpPr>
-          <p:cNvPr id="37" name="Text 35"/>
-          <p:cNvSpPr/>
-          <p:nvPr/>
-        </p:nvSpPr>
-        <p:spPr>
-          <a:xfrm>
-            <a:off x="5334000" y="1790700"/>
-            <a:ext cx="254000" cy="1968500"/>
-          </a:xfrm>
-          <a:prstGeom prst="rect">
-            <a:avLst/>
-          </a:prstGeom>
-          <a:noFill/>
-          <a:ln/>
-        </p:spPr>
-        <p:txBody>
-          <a:bodyPr wrap="square" lIns="0" tIns="0" rIns="0" bIns="0" rtlCol="0" anchor="ctr"/>
-          <a:lstStyle/>
-          <a:p>
-            <a:pPr algn="ctr" indent="0" marL="0">
-              <a:buNone/>
-            </a:pPr>
-            <a:r>
-              <a:rPr lang="en-US" sz="3000" dirty="0">
+      <p:pic>
+        <p:nvPicPr>
+          <p:cNvPr id="41" name="Image 6" descr="/home/ahmed/Projects/ai_llm_slides/videos/machine-learning/03_ridger_regression_gradient_descent/recreated_pptx/qa/slide003/parens/arc_midcol_L.png">    </p:cNvPr>
+          <p:cNvPicPr>
+            <a:picLocks noChangeAspect="1"/>
+          </p:cNvPicPr>
+          <p:nvPr/>
+        </p:nvPicPr>
+        <p:blipFill>
+          <a:blip r:embed="rId7"/>
+          <a:stretch>
+            <a:fillRect/>
+          </a:stretch>
+        </p:blipFill>
+        <p:spPr>
+          <a:xfrm>
+            <a:off x="5727700" y="1993900"/>
+            <a:ext cx="48260" cy="1193800"/>
+          </a:xfrm>
+          <a:prstGeom prst="rect">
+            <a:avLst/>
+          </a:prstGeom>
+        </p:spPr>
+      </p:pic>
+      <p:pic>
+        <p:nvPicPr>
+          <p:cNvPr id="42" name="Image 7" descr="/home/ahmed/Projects/ai_llm_slides/videos/machine-learning/03_ridger_regression_gradient_descent/recreated_pptx/qa/slide003/parens/arc_midcol_R.png">    </p:cNvPr>
+          <p:cNvPicPr>
+            <a:picLocks noChangeAspect="1"/>
+          </p:cNvPicPr>
+          <p:nvPr/>
+        </p:nvPicPr>
+        <p:blipFill>
+          <a:blip r:embed="rId8"/>
+          <a:stretch>
+            <a:fillRect/>
+          </a:stretch>
+        </p:blipFill>
+        <p:spPr>
+          <a:xfrm>
+            <a:off x="5943600" y="1993900"/>
+            <a:ext cx="48260" cy="1193800"/>
+          </a:xfrm>
+          <a:prstGeom prst="rect">
+            <a:avLst/>
+          </a:prstGeom>
+        </p:spPr>
+      </p:pic>
+      <p:sp>
+        <p:nvSpPr>
+          <p:cNvPr id="43" name="Text 33"/>
+          <p:cNvSpPr/>
+          <p:nvPr/>
+        </p:nvSpPr>
+        <p:spPr>
+          <a:xfrm>
+            <a:off x="5689600" y="2070100"/>
+            <a:ext cx="381000" cy="203200"/>
+          </a:xfrm>
+          <a:prstGeom prst="rect">
+            <a:avLst/>
+          </a:prstGeom>
+          <a:noFill/>
+          <a:ln/>
+        </p:spPr>
+        <p:txBody>
+          <a:bodyPr wrap="square" lIns="0" tIns="0" rIns="0" bIns="0" rtlCol="0" anchor="ctr"/>
+          <a:lstStyle/>
+          <a:p>
+            <a:pPr algn="ctr" indent="0" marL="0">
+              <a:buNone/>
+            </a:pPr>
+            <a:r>
+              <a:rPr lang="en-US" sz="1200" b="1" i="1" dirty="0">
                 <a:solidFill>
                   <a:srgbClr val="808080"/>
                 </a:solidFill>
@@ -2281,38 +2471,38 @@
                 <a:ea typeface="Arial" pitchFamily="34" charset="-122"/>
                 <a:cs typeface="Arial" pitchFamily="34" charset="-120"/>
               </a:rPr>
-              <a:t>(</a:t>
-            </a:r>
-            <a:endParaRPr lang="en-US" sz="3000" dirty="0"/>
-          </a:p>
-        </p:txBody>
-      </p:sp>
-      <p:sp>
-        <p:nvSpPr>
-          <p:cNvPr id="38" name="Text 36"/>
-          <p:cNvSpPr/>
-          <p:nvPr/>
-        </p:nvSpPr>
-        <p:spPr>
-          <a:xfrm>
-            <a:off x="5867400" y="1790700"/>
-            <a:ext cx="254000" cy="1968500"/>
-          </a:xfrm>
-          <a:prstGeom prst="rect">
-            <a:avLst/>
-          </a:prstGeom>
-          <a:noFill/>
-          <a:ln/>
-        </p:spPr>
-        <p:txBody>
-          <a:bodyPr wrap="square" lIns="0" tIns="0" rIns="0" bIns="0" rtlCol="0" anchor="ctr"/>
-          <a:lstStyle/>
-          <a:p>
-            <a:pPr algn="ctr" indent="0" marL="0">
-              <a:buNone/>
-            </a:pPr>
-            <a:r>
-              <a:rPr lang="en-US" sz="3000" dirty="0">
+              <a:t>...</a:t>
+            </a:r>
+            <a:endParaRPr lang="en-US" sz="1200" dirty="0"/>
+          </a:p>
+        </p:txBody>
+      </p:sp>
+      <p:sp>
+        <p:nvSpPr>
+          <p:cNvPr id="44" name="Text 34"/>
+          <p:cNvSpPr/>
+          <p:nvPr/>
+        </p:nvSpPr>
+        <p:spPr>
+          <a:xfrm>
+            <a:off x="5689600" y="2413000"/>
+            <a:ext cx="381000" cy="203200"/>
+          </a:xfrm>
+          <a:prstGeom prst="rect">
+            <a:avLst/>
+          </a:prstGeom>
+          <a:noFill/>
+          <a:ln/>
+        </p:spPr>
+        <p:txBody>
+          <a:bodyPr wrap="square" lIns="0" tIns="0" rIns="0" bIns="0" rtlCol="0" anchor="ctr"/>
+          <a:lstStyle/>
+          <a:p>
+            <a:pPr algn="ctr" indent="0" marL="0">
+              <a:buNone/>
+            </a:pPr>
+            <a:r>
+              <a:rPr lang="en-US" sz="1200" b="1" i="1" dirty="0">
                 <a:solidFill>
                   <a:srgbClr val="808080"/>
                 </a:solidFill>
@@ -2320,190 +2510,93 @@
                 <a:ea typeface="Arial" pitchFamily="34" charset="-122"/>
                 <a:cs typeface="Arial" pitchFamily="34" charset="-120"/>
               </a:rPr>
-              <a:t>)</a:t>
-            </a:r>
-            <a:endParaRPr lang="en-US" sz="3000" dirty="0"/>
-          </a:p>
-        </p:txBody>
-      </p:sp>
-      <p:sp>
-        <p:nvSpPr>
-          <p:cNvPr id="39" name="Shape 37"/>
-          <p:cNvSpPr/>
-          <p:nvPr/>
-        </p:nvSpPr>
-        <p:spPr>
-          <a:xfrm>
-            <a:off x="5657850" y="1930400"/>
-            <a:ext cx="38100" cy="38100"/>
-          </a:xfrm>
-          <a:prstGeom prst="ellipse">
-            <a:avLst/>
-          </a:prstGeom>
-          <a:solidFill>
-            <a:srgbClr val="808080"/>
-          </a:solidFill>
-          <a:ln w="12700">
-            <a:solidFill>
-              <a:srgbClr val="808080"/>
-            </a:solidFill>
-            <a:prstDash val="solid"/>
-          </a:ln>
-        </p:spPr>
-      </p:sp>
-      <p:sp>
-        <p:nvSpPr>
-          <p:cNvPr id="40" name="Shape 38"/>
-          <p:cNvSpPr/>
-          <p:nvPr/>
-        </p:nvSpPr>
-        <p:spPr>
-          <a:xfrm>
-            <a:off x="5657850" y="2171700"/>
-            <a:ext cx="38100" cy="38100"/>
-          </a:xfrm>
-          <a:prstGeom prst="ellipse">
-            <a:avLst/>
-          </a:prstGeom>
-          <a:solidFill>
-            <a:srgbClr val="808080"/>
-          </a:solidFill>
-          <a:ln w="12700">
-            <a:solidFill>
-              <a:srgbClr val="808080"/>
-            </a:solidFill>
-            <a:prstDash val="solid"/>
-          </a:ln>
-        </p:spPr>
-      </p:sp>
-      <p:sp>
-        <p:nvSpPr>
-          <p:cNvPr id="41" name="Shape 39"/>
-          <p:cNvSpPr/>
-          <p:nvPr/>
-        </p:nvSpPr>
-        <p:spPr>
-          <a:xfrm>
-            <a:off x="5657850" y="2413000"/>
-            <a:ext cx="38100" cy="38100"/>
-          </a:xfrm>
-          <a:prstGeom prst="ellipse">
-            <a:avLst/>
-          </a:prstGeom>
-          <a:solidFill>
-            <a:srgbClr val="808080"/>
-          </a:solidFill>
-          <a:ln w="12700">
-            <a:solidFill>
-              <a:srgbClr val="808080"/>
-            </a:solidFill>
-            <a:prstDash val="solid"/>
-          </a:ln>
-        </p:spPr>
-      </p:sp>
-      <p:sp>
-        <p:nvSpPr>
-          <p:cNvPr id="42" name="Shape 40"/>
-          <p:cNvSpPr/>
-          <p:nvPr/>
-        </p:nvSpPr>
-        <p:spPr>
-          <a:xfrm>
-            <a:off x="5657850" y="2654300"/>
-            <a:ext cx="38100" cy="38100"/>
-          </a:xfrm>
-          <a:prstGeom prst="ellipse">
-            <a:avLst/>
-          </a:prstGeom>
-          <a:solidFill>
-            <a:srgbClr val="808080"/>
-          </a:solidFill>
-          <a:ln w="12700">
-            <a:solidFill>
-              <a:srgbClr val="808080"/>
-            </a:solidFill>
-            <a:prstDash val="solid"/>
-          </a:ln>
-        </p:spPr>
-      </p:sp>
-      <p:sp>
-        <p:nvSpPr>
-          <p:cNvPr id="43" name="Shape 41"/>
-          <p:cNvSpPr/>
-          <p:nvPr/>
-        </p:nvSpPr>
-        <p:spPr>
-          <a:xfrm>
-            <a:off x="5657850" y="2895600"/>
-            <a:ext cx="38100" cy="38100"/>
-          </a:xfrm>
-          <a:prstGeom prst="ellipse">
-            <a:avLst/>
-          </a:prstGeom>
-          <a:solidFill>
-            <a:srgbClr val="808080"/>
-          </a:solidFill>
-          <a:ln w="12700">
-            <a:solidFill>
-              <a:srgbClr val="808080"/>
-            </a:solidFill>
-            <a:prstDash val="solid"/>
-          </a:ln>
-        </p:spPr>
-      </p:sp>
-      <p:sp>
-        <p:nvSpPr>
-          <p:cNvPr id="44" name="Shape 42"/>
-          <p:cNvSpPr/>
-          <p:nvPr/>
-        </p:nvSpPr>
-        <p:spPr>
-          <a:xfrm>
-            <a:off x="5657850" y="3136900"/>
-            <a:ext cx="38100" cy="38100"/>
-          </a:xfrm>
-          <a:prstGeom prst="ellipse">
-            <a:avLst/>
-          </a:prstGeom>
-          <a:solidFill>
-            <a:srgbClr val="808080"/>
-          </a:solidFill>
-          <a:ln w="12700">
-            <a:solidFill>
-              <a:srgbClr val="808080"/>
-            </a:solidFill>
-            <a:prstDash val="solid"/>
-          </a:ln>
-        </p:spPr>
-      </p:sp>
-      <p:sp>
-        <p:nvSpPr>
-          <p:cNvPr id="45" name="Shape 43"/>
-          <p:cNvSpPr/>
-          <p:nvPr/>
-        </p:nvSpPr>
-        <p:spPr>
-          <a:xfrm>
-            <a:off x="5657850" y="3378200"/>
-            <a:ext cx="38100" cy="38100"/>
-          </a:xfrm>
-          <a:prstGeom prst="ellipse">
-            <a:avLst/>
-          </a:prstGeom>
-          <a:solidFill>
-            <a:srgbClr val="808080"/>
-          </a:solidFill>
-          <a:ln w="12700">
-            <a:solidFill>
-              <a:srgbClr val="808080"/>
-            </a:solidFill>
-            <a:prstDash val="solid"/>
-          </a:ln>
-        </p:spPr>
-      </p:sp>
-      <p:sp>
-        <p:nvSpPr>
-          <p:cNvPr id="46" name="Shape 44"/>
+              <a:t>...</a:t>
+            </a:r>
+            <a:endParaRPr lang="en-US" sz="1200" dirty="0"/>
+          </a:p>
+        </p:txBody>
+      </p:sp>
+      <p:sp>
+        <p:nvSpPr>
+          <p:cNvPr id="45" name="Text 35"/>
+          <p:cNvSpPr/>
+          <p:nvPr/>
+        </p:nvSpPr>
+        <p:spPr>
+          <a:xfrm>
+            <a:off x="5689600" y="2717800"/>
+            <a:ext cx="381000" cy="203200"/>
+          </a:xfrm>
+          <a:prstGeom prst="rect">
+            <a:avLst/>
+          </a:prstGeom>
+          <a:noFill/>
+          <a:ln/>
+        </p:spPr>
+        <p:txBody>
+          <a:bodyPr wrap="square" lIns="0" tIns="0" rIns="0" bIns="0" rtlCol="0" anchor="ctr"/>
+          <a:lstStyle/>
+          <a:p>
+            <a:pPr algn="ctr" indent="0" marL="0">
+              <a:buNone/>
+            </a:pPr>
+            <a:r>
+              <a:rPr lang="en-US" sz="1200" b="1" i="1" dirty="0">
+                <a:solidFill>
+                  <a:srgbClr val="808080"/>
+                </a:solidFill>
+                <a:latin typeface="Arial" pitchFamily="34" charset="0"/>
+                <a:ea typeface="Arial" pitchFamily="34" charset="-122"/>
+                <a:cs typeface="Arial" pitchFamily="34" charset="-120"/>
+              </a:rPr>
+              <a:t>...</a:t>
+            </a:r>
+            <a:endParaRPr lang="en-US" sz="1200" dirty="0"/>
+          </a:p>
+        </p:txBody>
+      </p:sp>
+      <p:sp>
+        <p:nvSpPr>
+          <p:cNvPr id="46" name="Text 36"/>
+          <p:cNvSpPr/>
+          <p:nvPr/>
+        </p:nvSpPr>
+        <p:spPr>
+          <a:xfrm>
+            <a:off x="5689600" y="3060700"/>
+            <a:ext cx="381000" cy="203200"/>
+          </a:xfrm>
+          <a:prstGeom prst="rect">
+            <a:avLst/>
+          </a:prstGeom>
+          <a:noFill/>
+          <a:ln/>
+        </p:spPr>
+        <p:txBody>
+          <a:bodyPr wrap="square" lIns="0" tIns="0" rIns="0" bIns="0" rtlCol="0" anchor="ctr"/>
+          <a:lstStyle/>
+          <a:p>
+            <a:pPr algn="ctr" indent="0" marL="0">
+              <a:buNone/>
+            </a:pPr>
+            <a:r>
+              <a:rPr lang="en-US" sz="1200" b="1" i="1" dirty="0">
+                <a:solidFill>
+                  <a:srgbClr val="808080"/>
+                </a:solidFill>
+                <a:latin typeface="Arial" pitchFamily="34" charset="0"/>
+                <a:ea typeface="Arial" pitchFamily="34" charset="-122"/>
+                <a:cs typeface="Arial" pitchFamily="34" charset="-120"/>
+              </a:rPr>
+              <a:t>...</a:t>
+            </a:r>
+            <a:endParaRPr lang="en-US" sz="1200" dirty="0"/>
+          </a:p>
+        </p:txBody>
+      </p:sp>
+      <p:sp>
+        <p:nvSpPr>
+          <p:cNvPr id="47" name="Shape 37"/>
           <p:cNvSpPr/>
           <p:nvPr/>
         </p:nvSpPr>
@@ -2516,9 +2609,7 @@
             <a:avLst/>
           </a:prstGeom>
           <a:solidFill>
-            <a:srgbClr val="CCFFFF">
-              <a:alpha val="60000"/>
-            </a:srgbClr>
+            <a:srgbClr val="E5FEFA"/>
           </a:solidFill>
           <a:ln w="19050">
             <a:solidFill>
@@ -2530,7 +2621,7 @@
       </p:sp>
       <p:sp>
         <p:nvSpPr>
-          <p:cNvPr id="47" name="Text 45"/>
+          <p:cNvPr id="48" name="Text 38"/>
           <p:cNvSpPr/>
           <p:nvPr/>
         </p:nvSpPr>
@@ -2569,7 +2660,7 @@
       </p:sp>
       <p:sp>
         <p:nvSpPr>
-          <p:cNvPr id="48" name="Text 46"/>
+          <p:cNvPr id="49" name="Text 39"/>
           <p:cNvSpPr/>
           <p:nvPr/>
         </p:nvSpPr>
@@ -2592,9 +2683,9 @@
               <a:buNone/>
             </a:pPr>
             <a:r>
-              <a:rPr lang="en-US" sz="1800" i="1" dirty="0">
-                <a:solidFill>
-                  <a:srgbClr val="000000"/>
+              <a:rPr lang="en-US" sz="1800" b="1" i="1" u="sng" dirty="0">
+                <a:solidFill>
+                  <a:srgbClr val="0000FF"/>
                 </a:solidFill>
                 <a:latin typeface="Arial" pitchFamily="34" charset="0"/>
                 <a:ea typeface="Arial" pitchFamily="34" charset="-122"/>
@@ -2650,68 +2741,68 @@
             <a:r>
               <a:rPr lang="en-US" sz="1800" b="1" u="sng" dirty="0">
                 <a:solidFill>
+                  <a:srgbClr val="FF0000"/>
+                </a:solidFill>
+                <a:latin typeface="Arial" pitchFamily="34" charset="0"/>
+                <a:ea typeface="Arial" pitchFamily="34" charset="-122"/>
+                <a:cs typeface="Arial" pitchFamily="34" charset="-120"/>
+              </a:rPr>
+              <a:t>X</a:t>
+            </a:r>
+            <a:pPr algn="l" indent="0" marL="0">
+              <a:buNone/>
+            </a:pPr>
+            <a:r>
+              <a:rPr lang="en-US" sz="1800" dirty="0">
+                <a:solidFill>
+                  <a:srgbClr val="000000"/>
+                </a:solidFill>
+                <a:latin typeface="Arial" pitchFamily="34" charset="0"/>
+                <a:ea typeface="Arial" pitchFamily="34" charset="-122"/>
+                <a:cs typeface="Arial" pitchFamily="34" charset="-120"/>
+              </a:rPr>
+              <a:t> = </a:t>
+            </a:r>
+            <a:pPr algn="l" indent="0" marL="0">
+              <a:buNone/>
+            </a:pPr>
+            <a:r>
+              <a:rPr lang="en-US" sz="1800" b="1" u="sng" dirty="0">
+                <a:solidFill>
+                  <a:srgbClr val="FF0000"/>
+                </a:solidFill>
+                <a:latin typeface="Arial" pitchFamily="34" charset="0"/>
+                <a:ea typeface="Arial" pitchFamily="34" charset="-122"/>
+                <a:cs typeface="Arial" pitchFamily="34" charset="-120"/>
+              </a:rPr>
+              <a:t>X</a:t>
+            </a:r>
+            <a:pPr algn="l" indent="0" marL="0">
+              <a:buNone/>
+            </a:pPr>
+            <a:r>
+              <a:rPr lang="en-US" sz="1800" i="1" baseline="30000" dirty="0">
+                <a:solidFill>
+                  <a:srgbClr val="000000"/>
+                </a:solidFill>
+                <a:latin typeface="Arial" pitchFamily="34" charset="0"/>
+                <a:ea typeface="Arial" pitchFamily="34" charset="-122"/>
+                <a:cs typeface="Arial" pitchFamily="34" charset="-120"/>
+              </a:rPr>
+              <a:t>T</a:t>
+            </a:r>
+            <a:pPr algn="l" indent="0" marL="0">
+              <a:buNone/>
+            </a:pPr>
+            <a:r>
+              <a:rPr lang="en-US" sz="1800" b="1" u="sng" dirty="0">
+                <a:solidFill>
                   <a:srgbClr val="0000FF"/>
                 </a:solidFill>
                 <a:latin typeface="Arial" pitchFamily="34" charset="0"/>
                 <a:ea typeface="Arial" pitchFamily="34" charset="-122"/>
                 <a:cs typeface="Arial" pitchFamily="34" charset="-120"/>
               </a:rPr>
-              <a:t>X</a:t>
-            </a:r>
-            <a:pPr algn="l" indent="0" marL="0">
-              <a:buNone/>
-            </a:pPr>
-            <a:r>
-              <a:rPr lang="en-US" sz="1800" dirty="0">
-                <a:solidFill>
-                  <a:srgbClr val="000000"/>
-                </a:solidFill>
-                <a:latin typeface="Arial" pitchFamily="34" charset="0"/>
-                <a:ea typeface="Arial" pitchFamily="34" charset="-122"/>
-                <a:cs typeface="Arial" pitchFamily="34" charset="-120"/>
-              </a:rPr>
-              <a:t> = </a:t>
-            </a:r>
-            <a:pPr algn="l" indent="0" marL="0">
-              <a:buNone/>
-            </a:pPr>
-            <a:r>
-              <a:rPr lang="en-US" sz="1800" b="1" u="sng" dirty="0">
-                <a:solidFill>
-                  <a:srgbClr val="0000FF"/>
-                </a:solidFill>
-                <a:latin typeface="Arial" pitchFamily="34" charset="0"/>
-                <a:ea typeface="Arial" pitchFamily="34" charset="-122"/>
-                <a:cs typeface="Arial" pitchFamily="34" charset="-120"/>
-              </a:rPr>
-              <a:t>X</a:t>
-            </a:r>
-            <a:pPr algn="l" indent="0" marL="0">
-              <a:buNone/>
-            </a:pPr>
-            <a:r>
-              <a:rPr lang="en-US" sz="1800" i="1" baseline="30000" dirty="0">
-                <a:solidFill>
-                  <a:srgbClr val="000000"/>
-                </a:solidFill>
-                <a:latin typeface="Arial" pitchFamily="34" charset="0"/>
-                <a:ea typeface="Arial" pitchFamily="34" charset="-122"/>
-                <a:cs typeface="Arial" pitchFamily="34" charset="-120"/>
-              </a:rPr>
-              <a:t>T</a:t>
-            </a:r>
-            <a:pPr algn="l" indent="0" marL="0">
-              <a:buNone/>
-            </a:pPr>
-            <a:r>
-              <a:rPr lang="en-US" sz="1800" b="1" u="sng" dirty="0">
-                <a:solidFill>
-                  <a:srgbClr val="0000FF"/>
-                </a:solidFill>
-                <a:latin typeface="Arial" pitchFamily="34" charset="0"/>
-                <a:ea typeface="Arial" pitchFamily="34" charset="-122"/>
-                <a:cs typeface="Arial" pitchFamily="34" charset="-120"/>
-              </a:rPr>
               <a:t>W</a:t>
             </a:r>
             <a:endParaRPr lang="en-US" sz="1800" dirty="0"/>
@@ -2720,7 +2811,7 @@
       </p:sp>
       <p:sp>
         <p:nvSpPr>
-          <p:cNvPr id="49" name="Shape 47"/>
+          <p:cNvPr id="50" name="Shape 40"/>
           <p:cNvSpPr/>
           <p:nvPr/>
         </p:nvSpPr>
@@ -2745,7 +2836,7 @@
       </p:sp>
       <p:sp>
         <p:nvSpPr>
-          <p:cNvPr id="50" name="Text 48"/>
+          <p:cNvPr id="51" name="Text 41"/>
           <p:cNvSpPr/>
           <p:nvPr/>
         </p:nvSpPr>
@@ -2826,7 +2917,7 @@
       </p:sp>
       <p:sp>
         <p:nvSpPr>
-          <p:cNvPr id="51" name="Shape 49"/>
+          <p:cNvPr id="52" name="Shape 42"/>
           <p:cNvSpPr/>
           <p:nvPr/>
         </p:nvSpPr>
@@ -2851,19 +2942,1418 @@
       </p:sp>
       <p:sp>
         <p:nvSpPr>
-          <p:cNvPr id="52" name="Shape 50"/>
-          <p:cNvSpPr/>
-          <p:nvPr/>
-        </p:nvSpPr>
-        <p:spPr>
-          <a:xfrm>
-            <a:off x="1041400" y="4241800"/>
-            <a:ext cx="114300" cy="1778000"/>
-          </a:xfrm>
-          <a:prstGeom prst="leftBracket">
-            <a:avLst/>
-          </a:prstGeom>
-          <a:ln w="12700">
+          <p:cNvPr id="53" name="Shape 43"/>
+          <p:cNvSpPr/>
+          <p:nvPr/>
+        </p:nvSpPr>
+        <p:spPr>
+          <a:xfrm>
+            <a:off x="2489200" y="4673600"/>
+            <a:ext cx="2501900" cy="279400"/>
+          </a:xfrm>
+          <a:prstGeom prst="rect">
+            <a:avLst/>
+          </a:prstGeom>
+          <a:solidFill>
+            <a:srgbClr val="FFFF99"/>
+          </a:solidFill>
+          <a:ln/>
+        </p:spPr>
+      </p:sp>
+      <p:sp>
+        <p:nvSpPr>
+          <p:cNvPr id="54" name="Shape 44"/>
+          <p:cNvSpPr/>
+          <p:nvPr/>
+        </p:nvSpPr>
+        <p:spPr>
+          <a:xfrm>
+            <a:off x="2489200" y="5041900"/>
+            <a:ext cx="2501900" cy="330200"/>
+          </a:xfrm>
+          <a:prstGeom prst="rect">
+            <a:avLst/>
+          </a:prstGeom>
+          <a:solidFill>
+            <a:srgbClr val="CCFFFF"/>
+          </a:solidFill>
+          <a:ln/>
+        </p:spPr>
+      </p:sp>
+      <p:sp>
+        <p:nvSpPr>
+          <p:cNvPr id="55" name="Shape 45"/>
+          <p:cNvSpPr/>
+          <p:nvPr/>
+        </p:nvSpPr>
+        <p:spPr>
+          <a:xfrm>
+            <a:off x="2489200" y="5791200"/>
+            <a:ext cx="2501900" cy="279400"/>
+          </a:xfrm>
+          <a:prstGeom prst="rect">
+            <a:avLst/>
+          </a:prstGeom>
+          <a:solidFill>
+            <a:srgbClr val="F0A0F0"/>
+          </a:solidFill>
+          <a:ln/>
+        </p:spPr>
+      </p:sp>
+      <p:sp>
+        <p:nvSpPr>
+          <p:cNvPr id="56" name="Shape 46"/>
+          <p:cNvSpPr/>
+          <p:nvPr/>
+        </p:nvSpPr>
+        <p:spPr>
+          <a:xfrm>
+            <a:off x="1371600" y="4673600"/>
+            <a:ext cx="355600" cy="292100"/>
+          </a:xfrm>
+          <a:prstGeom prst="rect">
+            <a:avLst/>
+          </a:prstGeom>
+          <a:solidFill>
+            <a:srgbClr val="FFFF99"/>
+          </a:solidFill>
+          <a:ln/>
+        </p:spPr>
+      </p:sp>
+      <p:sp>
+        <p:nvSpPr>
+          <p:cNvPr id="57" name="Shape 47"/>
+          <p:cNvSpPr/>
+          <p:nvPr/>
+        </p:nvSpPr>
+        <p:spPr>
+          <a:xfrm>
+            <a:off x="1371600" y="5067300"/>
+            <a:ext cx="355600" cy="304800"/>
+          </a:xfrm>
+          <a:prstGeom prst="rect">
+            <a:avLst/>
+          </a:prstGeom>
+          <a:solidFill>
+            <a:srgbClr val="CCFFFF"/>
+          </a:solidFill>
+          <a:ln/>
+        </p:spPr>
+      </p:sp>
+      <p:sp>
+        <p:nvSpPr>
+          <p:cNvPr id="58" name="Shape 48"/>
+          <p:cNvSpPr/>
+          <p:nvPr/>
+        </p:nvSpPr>
+        <p:spPr>
+          <a:xfrm>
+            <a:off x="1371600" y="5778500"/>
+            <a:ext cx="355600" cy="304800"/>
+          </a:xfrm>
+          <a:prstGeom prst="rect">
+            <a:avLst/>
+          </a:prstGeom>
+          <a:solidFill>
+            <a:srgbClr val="F0A0F0"/>
+          </a:solidFill>
+          <a:ln/>
+        </p:spPr>
+      </p:sp>
+      <p:pic>
+        <p:nvPicPr>
+          <p:cNvPr id="59" name="Image 8" descr="/home/ahmed/Projects/ai_llm_slides/videos/machine-learning/03_ridger_regression_gradient_descent/recreated_pptx/qa/slide003/parens/arc_yvec_L.png">    </p:cNvPr>
+          <p:cNvPicPr>
+            <a:picLocks noChangeAspect="1"/>
+          </p:cNvPicPr>
+          <p:nvPr/>
+        </p:nvPicPr>
+        <p:blipFill>
+          <a:blip r:embed="rId9"/>
+          <a:stretch>
+            <a:fillRect/>
+          </a:stretch>
+        </p:blipFill>
+        <p:spPr>
+          <a:xfrm>
+            <a:off x="1358900" y="4546600"/>
+            <a:ext cx="48260" cy="1625600"/>
+          </a:xfrm>
+          <a:prstGeom prst="rect">
+            <a:avLst/>
+          </a:prstGeom>
+        </p:spPr>
+      </p:pic>
+      <p:pic>
+        <p:nvPicPr>
+          <p:cNvPr id="60" name="Image 9" descr="/home/ahmed/Projects/ai_llm_slides/videos/machine-learning/03_ridger_regression_gradient_descent/recreated_pptx/qa/slide003/parens/arc_yvec_R.png">    </p:cNvPr>
+          <p:cNvPicPr>
+            <a:picLocks noChangeAspect="1"/>
+          </p:cNvPicPr>
+          <p:nvPr/>
+        </p:nvPicPr>
+        <p:blipFill>
+          <a:blip r:embed="rId10"/>
+          <a:stretch>
+            <a:fillRect/>
+          </a:stretch>
+        </p:blipFill>
+        <p:spPr>
+          <a:xfrm>
+            <a:off x="1638300" y="4546600"/>
+            <a:ext cx="48260" cy="1625600"/>
+          </a:xfrm>
+          <a:prstGeom prst="rect">
+            <a:avLst/>
+          </a:prstGeom>
+        </p:spPr>
+      </p:pic>
+      <p:sp>
+        <p:nvSpPr>
+          <p:cNvPr id="61" name="Text 49"/>
+          <p:cNvSpPr/>
+          <p:nvPr/>
+        </p:nvSpPr>
+        <p:spPr>
+          <a:xfrm>
+            <a:off x="1384300" y="4673600"/>
+            <a:ext cx="431800" cy="279400"/>
+          </a:xfrm>
+          <a:prstGeom prst="rect">
+            <a:avLst/>
+          </a:prstGeom>
+          <a:noFill/>
+          <a:ln/>
+        </p:spPr>
+        <p:txBody>
+          <a:bodyPr wrap="square" lIns="0" tIns="0" rIns="0" bIns="0" rtlCol="0" anchor="ctr"/>
+          <a:lstStyle/>
+          <a:p>
+            <a:pPr algn="ctr" indent="0" marL="0">
+              <a:buNone/>
+            </a:pPr>
+            <a:r>
+              <a:rPr lang="en-US" sz="1500" i="1" dirty="0">
+                <a:solidFill>
+                  <a:srgbClr val="C8963C"/>
+                </a:solidFill>
+                <a:latin typeface="Arial" pitchFamily="34" charset="0"/>
+                <a:ea typeface="Arial" pitchFamily="34" charset="-122"/>
+                <a:cs typeface="Arial" pitchFamily="34" charset="-120"/>
+              </a:rPr>
+              <a:t>y</a:t>
+            </a:r>
+            <a:pPr algn="ctr" indent="0" marL="0">
+              <a:buNone/>
+            </a:pPr>
+            <a:r>
+              <a:rPr lang="en-US" sz="1500" i="1" baseline="-40000" dirty="0">
+                <a:solidFill>
+                  <a:srgbClr val="C8963C"/>
+                </a:solidFill>
+                <a:latin typeface="Arial" pitchFamily="34" charset="0"/>
+                <a:ea typeface="Arial" pitchFamily="34" charset="-122"/>
+                <a:cs typeface="Arial" pitchFamily="34" charset="-120"/>
+              </a:rPr>
+              <a:t>1</a:t>
+            </a:r>
+            <a:endParaRPr lang="en-US" sz="1500" dirty="0"/>
+          </a:p>
+        </p:txBody>
+      </p:sp>
+      <p:sp>
+        <p:nvSpPr>
+          <p:cNvPr id="62" name="Text 50"/>
+          <p:cNvSpPr/>
+          <p:nvPr/>
+        </p:nvSpPr>
+        <p:spPr>
+          <a:xfrm>
+            <a:off x="1384300" y="5041900"/>
+            <a:ext cx="431800" cy="330200"/>
+          </a:xfrm>
+          <a:prstGeom prst="rect">
+            <a:avLst/>
+          </a:prstGeom>
+          <a:noFill/>
+          <a:ln/>
+        </p:spPr>
+        <p:txBody>
+          <a:bodyPr wrap="square" lIns="0" tIns="0" rIns="0" bIns="0" rtlCol="0" anchor="ctr"/>
+          <a:lstStyle/>
+          <a:p>
+            <a:pPr algn="ctr" indent="0" marL="0">
+              <a:buNone/>
+            </a:pPr>
+            <a:r>
+              <a:rPr lang="en-US" sz="1500" i="1" dirty="0">
+                <a:solidFill>
+                  <a:srgbClr val="46A0A8"/>
+                </a:solidFill>
+                <a:latin typeface="Arial" pitchFamily="34" charset="0"/>
+                <a:ea typeface="Arial" pitchFamily="34" charset="-122"/>
+                <a:cs typeface="Arial" pitchFamily="34" charset="-120"/>
+              </a:rPr>
+              <a:t>y</a:t>
+            </a:r>
+            <a:pPr algn="ctr" indent="0" marL="0">
+              <a:buNone/>
+            </a:pPr>
+            <a:r>
+              <a:rPr lang="en-US" sz="1500" i="1" baseline="-40000" dirty="0">
+                <a:solidFill>
+                  <a:srgbClr val="46A0A8"/>
+                </a:solidFill>
+                <a:latin typeface="Arial" pitchFamily="34" charset="0"/>
+                <a:ea typeface="Arial" pitchFamily="34" charset="-122"/>
+                <a:cs typeface="Arial" pitchFamily="34" charset="-120"/>
+              </a:rPr>
+              <a:t>2</a:t>
+            </a:r>
+            <a:endParaRPr lang="en-US" sz="1500" dirty="0"/>
+          </a:p>
+        </p:txBody>
+      </p:sp>
+      <p:sp>
+        <p:nvSpPr>
+          <p:cNvPr id="63" name="Text 51"/>
+          <p:cNvSpPr/>
+          <p:nvPr/>
+        </p:nvSpPr>
+        <p:spPr>
+          <a:xfrm>
+            <a:off x="1384300" y="5422900"/>
+            <a:ext cx="431800" cy="317500"/>
+          </a:xfrm>
+          <a:prstGeom prst="rect">
+            <a:avLst/>
+          </a:prstGeom>
+          <a:noFill/>
+          <a:ln/>
+        </p:spPr>
+        <p:txBody>
+          <a:bodyPr wrap="square" lIns="0" tIns="0" rIns="0" bIns="0" rtlCol="0" anchor="ctr"/>
+          <a:lstStyle/>
+          <a:p>
+            <a:pPr algn="ctr" indent="0" marL="0">
+              <a:buNone/>
+            </a:pPr>
+            <a:r>
+              <a:rPr lang="en-US" sz="1500" i="1" dirty="0">
+                <a:solidFill>
+                  <a:srgbClr val="C00000"/>
+                </a:solidFill>
+                <a:latin typeface="Arial" pitchFamily="34" charset="0"/>
+                <a:ea typeface="Arial" pitchFamily="34" charset="-122"/>
+                <a:cs typeface="Arial" pitchFamily="34" charset="-120"/>
+              </a:rPr>
+              <a:t>...</a:t>
+            </a:r>
+            <a:endParaRPr lang="en-US" sz="1500" dirty="0"/>
+          </a:p>
+        </p:txBody>
+      </p:sp>
+      <p:sp>
+        <p:nvSpPr>
+          <p:cNvPr id="64" name="Text 52"/>
+          <p:cNvSpPr/>
+          <p:nvPr/>
+        </p:nvSpPr>
+        <p:spPr>
+          <a:xfrm>
+            <a:off x="1384300" y="5791200"/>
+            <a:ext cx="431800" cy="304800"/>
+          </a:xfrm>
+          <a:prstGeom prst="rect">
+            <a:avLst/>
+          </a:prstGeom>
+          <a:noFill/>
+          <a:ln/>
+        </p:spPr>
+        <p:txBody>
+          <a:bodyPr wrap="square" lIns="0" tIns="0" rIns="0" bIns="0" rtlCol="0" anchor="ctr"/>
+          <a:lstStyle/>
+          <a:p>
+            <a:pPr algn="ctr" indent="0" marL="0">
+              <a:buNone/>
+            </a:pPr>
+            <a:r>
+              <a:rPr lang="en-US" sz="1500" i="1" dirty="0">
+                <a:solidFill>
+                  <a:srgbClr val="CC3FB0"/>
+                </a:solidFill>
+                <a:latin typeface="Arial" pitchFamily="34" charset="0"/>
+                <a:ea typeface="Arial" pitchFamily="34" charset="-122"/>
+                <a:cs typeface="Arial" pitchFamily="34" charset="-120"/>
+              </a:rPr>
+              <a:t>y</a:t>
+            </a:r>
+            <a:pPr algn="ctr" indent="0" marL="0">
+              <a:buNone/>
+            </a:pPr>
+            <a:r>
+              <a:rPr lang="en-US" sz="1500" i="1" baseline="-40000" dirty="0">
+                <a:solidFill>
+                  <a:srgbClr val="CC3FB0"/>
+                </a:solidFill>
+                <a:latin typeface="Arial" pitchFamily="34" charset="0"/>
+                <a:ea typeface="Arial" pitchFamily="34" charset="-122"/>
+                <a:cs typeface="Arial" pitchFamily="34" charset="-120"/>
+              </a:rPr>
+              <a:t>n</a:t>
+            </a:r>
+            <a:endParaRPr lang="en-US" sz="1500" dirty="0"/>
+          </a:p>
+        </p:txBody>
+      </p:sp>
+      <p:sp>
+        <p:nvSpPr>
+          <p:cNvPr id="65" name="Text 53"/>
+          <p:cNvSpPr/>
+          <p:nvPr/>
+        </p:nvSpPr>
+        <p:spPr>
+          <a:xfrm>
+            <a:off x="1778000" y="5867400"/>
+            <a:ext cx="762000" cy="228600"/>
+          </a:xfrm>
+          <a:prstGeom prst="rect">
+            <a:avLst/>
+          </a:prstGeom>
+          <a:noFill/>
+          <a:ln/>
+        </p:spPr>
+        <p:txBody>
+          <a:bodyPr wrap="square" lIns="0" tIns="0" rIns="0" bIns="0" rtlCol="0" anchor="t"/>
+          <a:lstStyle/>
+          <a:p>
+            <a:pPr algn="l" indent="0" marL="0">
+              <a:buNone/>
+            </a:pPr>
+            <a:r>
+              <a:rPr lang="en-US" sz="1100" b="1" dirty="0">
+                <a:solidFill>
+                  <a:srgbClr val="C00000"/>
+                </a:solidFill>
+                <a:latin typeface="Arial" pitchFamily="34" charset="0"/>
+                <a:ea typeface="Arial" pitchFamily="34" charset="-122"/>
+                <a:cs typeface="Arial" pitchFamily="34" charset="-120"/>
+              </a:rPr>
+              <a:t>N × 1</a:t>
+            </a:r>
+            <a:endParaRPr lang="en-US" sz="1100" dirty="0"/>
+          </a:p>
+        </p:txBody>
+      </p:sp>
+      <p:sp>
+        <p:nvSpPr>
+          <p:cNvPr id="66" name="Text 54"/>
+          <p:cNvSpPr/>
+          <p:nvPr/>
+        </p:nvSpPr>
+        <p:spPr>
+          <a:xfrm>
+            <a:off x="1828800" y="4914900"/>
+            <a:ext cx="304800" cy="381000"/>
+          </a:xfrm>
+          <a:prstGeom prst="rect">
+            <a:avLst/>
+          </a:prstGeom>
+          <a:noFill/>
+          <a:ln/>
+        </p:spPr>
+        <p:txBody>
+          <a:bodyPr wrap="square" lIns="0" tIns="0" rIns="0" bIns="0" rtlCol="0" anchor="ctr"/>
+          <a:lstStyle/>
+          <a:p>
+            <a:pPr algn="ctr" indent="0" marL="0">
+              <a:buNone/>
+            </a:pPr>
+            <a:r>
+              <a:rPr lang="en-US" sz="2400" b="1" dirty="0">
+                <a:solidFill>
+                  <a:srgbClr val="000000"/>
+                </a:solidFill>
+                <a:latin typeface="Arial" pitchFamily="34" charset="0"/>
+                <a:ea typeface="Arial" pitchFamily="34" charset="-122"/>
+                <a:cs typeface="Arial" pitchFamily="34" charset="-120"/>
+              </a:rPr>
+              <a:t>=</a:t>
+            </a:r>
+            <a:endParaRPr lang="en-US" sz="2400" dirty="0"/>
+          </a:p>
+        </p:txBody>
+      </p:sp>
+      <p:sp>
+        <p:nvSpPr>
+          <p:cNvPr id="67" name="Text 55"/>
+          <p:cNvSpPr/>
+          <p:nvPr/>
+        </p:nvSpPr>
+        <p:spPr>
+          <a:xfrm>
+            <a:off x="2654300" y="4673600"/>
+            <a:ext cx="508000" cy="279400"/>
+          </a:xfrm>
+          <a:prstGeom prst="rect">
+            <a:avLst/>
+          </a:prstGeom>
+          <a:noFill/>
+          <a:ln/>
+        </p:spPr>
+        <p:txBody>
+          <a:bodyPr wrap="square" lIns="0" tIns="0" rIns="0" bIns="0" rtlCol="0" anchor="ctr"/>
+          <a:lstStyle/>
+          <a:p>
+            <a:pPr algn="l" indent="0" marL="0">
+              <a:buNone/>
+            </a:pPr>
+            <a:r>
+              <a:rPr lang="en-US" sz="1000" i="1" dirty="0">
+                <a:solidFill>
+                  <a:srgbClr val="000000"/>
+                </a:solidFill>
+                <a:latin typeface="Arial" pitchFamily="34" charset="0"/>
+                <a:ea typeface="Arial" pitchFamily="34" charset="-122"/>
+                <a:cs typeface="Arial" pitchFamily="34" charset="-120"/>
+              </a:rPr>
+              <a:t>1</a:t>
+            </a:r>
+            <a:endParaRPr lang="en-US" sz="1000" dirty="0"/>
+          </a:p>
+        </p:txBody>
+      </p:sp>
+      <p:sp>
+        <p:nvSpPr>
+          <p:cNvPr id="68" name="Text 56"/>
+          <p:cNvSpPr/>
+          <p:nvPr/>
+        </p:nvSpPr>
+        <p:spPr>
+          <a:xfrm>
+            <a:off x="3111500" y="4673600"/>
+            <a:ext cx="508000" cy="279400"/>
+          </a:xfrm>
+          <a:prstGeom prst="rect">
+            <a:avLst/>
+          </a:prstGeom>
+          <a:noFill/>
+          <a:ln/>
+        </p:spPr>
+        <p:txBody>
+          <a:bodyPr wrap="square" lIns="0" tIns="0" rIns="0" bIns="0" rtlCol="0" anchor="ctr"/>
+          <a:lstStyle/>
+          <a:p>
+            <a:pPr algn="l" indent="0" marL="0">
+              <a:buNone/>
+            </a:pPr>
+            <a:r>
+              <a:rPr lang="en-US" sz="1000" i="1" dirty="0">
+                <a:solidFill>
+                  <a:srgbClr val="000000"/>
+                </a:solidFill>
+                <a:latin typeface="Arial" pitchFamily="34" charset="0"/>
+                <a:ea typeface="Arial" pitchFamily="34" charset="-122"/>
+                <a:cs typeface="Arial" pitchFamily="34" charset="-120"/>
+              </a:rPr>
+              <a:t>x</a:t>
+            </a:r>
+            <a:pPr algn="l" indent="0" marL="0">
+              <a:buNone/>
+            </a:pPr>
+            <a:r>
+              <a:rPr lang="en-US" sz="1000" i="1" baseline="-40000" dirty="0">
+                <a:solidFill>
+                  <a:srgbClr val="000000"/>
+                </a:solidFill>
+                <a:latin typeface="Arial" pitchFamily="34" charset="0"/>
+                <a:ea typeface="Arial" pitchFamily="34" charset="-122"/>
+                <a:cs typeface="Arial" pitchFamily="34" charset="-120"/>
+              </a:rPr>
+              <a:t>11</a:t>
+            </a:r>
+            <a:endParaRPr lang="en-US" sz="1000" dirty="0"/>
+          </a:p>
+        </p:txBody>
+      </p:sp>
+      <p:sp>
+        <p:nvSpPr>
+          <p:cNvPr id="69" name="Text 57"/>
+          <p:cNvSpPr/>
+          <p:nvPr/>
+        </p:nvSpPr>
+        <p:spPr>
+          <a:xfrm>
+            <a:off x="3683000" y="4673600"/>
+            <a:ext cx="508000" cy="279400"/>
+          </a:xfrm>
+          <a:prstGeom prst="rect">
+            <a:avLst/>
+          </a:prstGeom>
+          <a:noFill/>
+          <a:ln/>
+        </p:spPr>
+        <p:txBody>
+          <a:bodyPr wrap="square" lIns="0" tIns="0" rIns="0" bIns="0" rtlCol="0" anchor="ctr"/>
+          <a:lstStyle/>
+          <a:p>
+            <a:pPr algn="l" indent="0" marL="0">
+              <a:buNone/>
+            </a:pPr>
+            <a:r>
+              <a:rPr lang="en-US" sz="1000" i="1" dirty="0">
+                <a:solidFill>
+                  <a:srgbClr val="000000"/>
+                </a:solidFill>
+                <a:latin typeface="Arial" pitchFamily="34" charset="0"/>
+                <a:ea typeface="Arial" pitchFamily="34" charset="-122"/>
+                <a:cs typeface="Arial" pitchFamily="34" charset="-120"/>
+              </a:rPr>
+              <a:t>x</a:t>
+            </a:r>
+            <a:pPr algn="l" indent="0" marL="0">
+              <a:buNone/>
+            </a:pPr>
+            <a:r>
+              <a:rPr lang="en-US" sz="1000" i="1" baseline="-40000" dirty="0">
+                <a:solidFill>
+                  <a:srgbClr val="000000"/>
+                </a:solidFill>
+                <a:latin typeface="Arial" pitchFamily="34" charset="0"/>
+                <a:ea typeface="Arial" pitchFamily="34" charset="-122"/>
+                <a:cs typeface="Arial" pitchFamily="34" charset="-120"/>
+              </a:rPr>
+              <a:t>12</a:t>
+            </a:r>
+            <a:endParaRPr lang="en-US" sz="1000" dirty="0"/>
+          </a:p>
+        </p:txBody>
+      </p:sp>
+      <p:sp>
+        <p:nvSpPr>
+          <p:cNvPr id="70" name="Text 58"/>
+          <p:cNvSpPr/>
+          <p:nvPr/>
+        </p:nvSpPr>
+        <p:spPr>
+          <a:xfrm>
+            <a:off x="4191000" y="4673600"/>
+            <a:ext cx="508000" cy="279400"/>
+          </a:xfrm>
+          <a:prstGeom prst="rect">
+            <a:avLst/>
+          </a:prstGeom>
+          <a:noFill/>
+          <a:ln/>
+        </p:spPr>
+        <p:txBody>
+          <a:bodyPr wrap="square" lIns="0" tIns="0" rIns="0" bIns="0" rtlCol="0" anchor="ctr"/>
+          <a:lstStyle/>
+          <a:p>
+            <a:pPr algn="l" indent="0" marL="0">
+              <a:buNone/>
+            </a:pPr>
+            <a:r>
+              <a:rPr lang="en-US" sz="1000" i="1" dirty="0">
+                <a:solidFill>
+                  <a:srgbClr val="000000"/>
+                </a:solidFill>
+                <a:latin typeface="Arial" pitchFamily="34" charset="0"/>
+                <a:ea typeface="Arial" pitchFamily="34" charset="-122"/>
+                <a:cs typeface="Arial" pitchFamily="34" charset="-120"/>
+              </a:rPr>
+              <a:t>...</a:t>
+            </a:r>
+            <a:endParaRPr lang="en-US" sz="1000" dirty="0"/>
+          </a:p>
+        </p:txBody>
+      </p:sp>
+      <p:sp>
+        <p:nvSpPr>
+          <p:cNvPr id="71" name="Text 59"/>
+          <p:cNvSpPr/>
+          <p:nvPr/>
+        </p:nvSpPr>
+        <p:spPr>
+          <a:xfrm>
+            <a:off x="4635500" y="4673600"/>
+            <a:ext cx="508000" cy="279400"/>
+          </a:xfrm>
+          <a:prstGeom prst="rect">
+            <a:avLst/>
+          </a:prstGeom>
+          <a:noFill/>
+          <a:ln/>
+        </p:spPr>
+        <p:txBody>
+          <a:bodyPr wrap="square" lIns="0" tIns="0" rIns="0" bIns="0" rtlCol="0" anchor="ctr"/>
+          <a:lstStyle/>
+          <a:p>
+            <a:pPr algn="l" indent="0" marL="0">
+              <a:buNone/>
+            </a:pPr>
+            <a:r>
+              <a:rPr lang="en-US" sz="1000" i="1" dirty="0">
+                <a:solidFill>
+                  <a:srgbClr val="000000"/>
+                </a:solidFill>
+                <a:latin typeface="Arial" pitchFamily="34" charset="0"/>
+                <a:ea typeface="Arial" pitchFamily="34" charset="-122"/>
+                <a:cs typeface="Arial" pitchFamily="34" charset="-120"/>
+              </a:rPr>
+              <a:t>x</a:t>
+            </a:r>
+            <a:pPr algn="l" indent="0" marL="0">
+              <a:buNone/>
+            </a:pPr>
+            <a:r>
+              <a:rPr lang="en-US" sz="1000" i="1" baseline="-40000" dirty="0">
+                <a:solidFill>
+                  <a:srgbClr val="000000"/>
+                </a:solidFill>
+                <a:latin typeface="Arial" pitchFamily="34" charset="0"/>
+                <a:ea typeface="Arial" pitchFamily="34" charset="-122"/>
+                <a:cs typeface="Arial" pitchFamily="34" charset="-120"/>
+              </a:rPr>
+              <a:t>1d</a:t>
+            </a:r>
+            <a:endParaRPr lang="en-US" sz="1000" dirty="0"/>
+          </a:p>
+        </p:txBody>
+      </p:sp>
+      <p:sp>
+        <p:nvSpPr>
+          <p:cNvPr id="72" name="Text 60"/>
+          <p:cNvSpPr/>
+          <p:nvPr/>
+        </p:nvSpPr>
+        <p:spPr>
+          <a:xfrm>
+            <a:off x="2654300" y="5041900"/>
+            <a:ext cx="508000" cy="330200"/>
+          </a:xfrm>
+          <a:prstGeom prst="rect">
+            <a:avLst/>
+          </a:prstGeom>
+          <a:noFill/>
+          <a:ln/>
+        </p:spPr>
+        <p:txBody>
+          <a:bodyPr wrap="square" lIns="0" tIns="0" rIns="0" bIns="0" rtlCol="0" anchor="ctr"/>
+          <a:lstStyle/>
+          <a:p>
+            <a:pPr algn="l" indent="0" marL="0">
+              <a:buNone/>
+            </a:pPr>
+            <a:r>
+              <a:rPr lang="en-US" sz="1000" i="1" dirty="0">
+                <a:solidFill>
+                  <a:srgbClr val="000000"/>
+                </a:solidFill>
+                <a:latin typeface="Arial" pitchFamily="34" charset="0"/>
+                <a:ea typeface="Arial" pitchFamily="34" charset="-122"/>
+                <a:cs typeface="Arial" pitchFamily="34" charset="-120"/>
+              </a:rPr>
+              <a:t>1</a:t>
+            </a:r>
+            <a:endParaRPr lang="en-US" sz="1000" dirty="0"/>
+          </a:p>
+        </p:txBody>
+      </p:sp>
+      <p:sp>
+        <p:nvSpPr>
+          <p:cNvPr id="73" name="Text 61"/>
+          <p:cNvSpPr/>
+          <p:nvPr/>
+        </p:nvSpPr>
+        <p:spPr>
+          <a:xfrm>
+            <a:off x="3111500" y="5041900"/>
+            <a:ext cx="508000" cy="330200"/>
+          </a:xfrm>
+          <a:prstGeom prst="rect">
+            <a:avLst/>
+          </a:prstGeom>
+          <a:noFill/>
+          <a:ln/>
+        </p:spPr>
+        <p:txBody>
+          <a:bodyPr wrap="square" lIns="0" tIns="0" rIns="0" bIns="0" rtlCol="0" anchor="ctr"/>
+          <a:lstStyle/>
+          <a:p>
+            <a:pPr algn="l" indent="0" marL="0">
+              <a:buNone/>
+            </a:pPr>
+            <a:r>
+              <a:rPr lang="en-US" sz="1000" i="1" dirty="0">
+                <a:solidFill>
+                  <a:srgbClr val="000000"/>
+                </a:solidFill>
+                <a:latin typeface="Arial" pitchFamily="34" charset="0"/>
+                <a:ea typeface="Arial" pitchFamily="34" charset="-122"/>
+                <a:cs typeface="Arial" pitchFamily="34" charset="-120"/>
+              </a:rPr>
+              <a:t>x</a:t>
+            </a:r>
+            <a:pPr algn="l" indent="0" marL="0">
+              <a:buNone/>
+            </a:pPr>
+            <a:r>
+              <a:rPr lang="en-US" sz="1000" i="1" baseline="-40000" dirty="0">
+                <a:solidFill>
+                  <a:srgbClr val="000000"/>
+                </a:solidFill>
+                <a:latin typeface="Arial" pitchFamily="34" charset="0"/>
+                <a:ea typeface="Arial" pitchFamily="34" charset="-122"/>
+                <a:cs typeface="Arial" pitchFamily="34" charset="-120"/>
+              </a:rPr>
+              <a:t>21</a:t>
+            </a:r>
+            <a:endParaRPr lang="en-US" sz="1000" dirty="0"/>
+          </a:p>
+        </p:txBody>
+      </p:sp>
+      <p:sp>
+        <p:nvSpPr>
+          <p:cNvPr id="74" name="Text 62"/>
+          <p:cNvSpPr/>
+          <p:nvPr/>
+        </p:nvSpPr>
+        <p:spPr>
+          <a:xfrm>
+            <a:off x="3683000" y="5041900"/>
+            <a:ext cx="508000" cy="330200"/>
+          </a:xfrm>
+          <a:prstGeom prst="rect">
+            <a:avLst/>
+          </a:prstGeom>
+          <a:noFill/>
+          <a:ln/>
+        </p:spPr>
+        <p:txBody>
+          <a:bodyPr wrap="square" lIns="0" tIns="0" rIns="0" bIns="0" rtlCol="0" anchor="ctr"/>
+          <a:lstStyle/>
+          <a:p>
+            <a:pPr algn="l" indent="0" marL="0">
+              <a:buNone/>
+            </a:pPr>
+            <a:r>
+              <a:rPr lang="en-US" sz="1000" i="1" dirty="0">
+                <a:solidFill>
+                  <a:srgbClr val="000000"/>
+                </a:solidFill>
+                <a:latin typeface="Arial" pitchFamily="34" charset="0"/>
+                <a:ea typeface="Arial" pitchFamily="34" charset="-122"/>
+                <a:cs typeface="Arial" pitchFamily="34" charset="-120"/>
+              </a:rPr>
+              <a:t>x</a:t>
+            </a:r>
+            <a:pPr algn="l" indent="0" marL="0">
+              <a:buNone/>
+            </a:pPr>
+            <a:r>
+              <a:rPr lang="en-US" sz="1000" i="1" baseline="-40000" dirty="0">
+                <a:solidFill>
+                  <a:srgbClr val="000000"/>
+                </a:solidFill>
+                <a:latin typeface="Arial" pitchFamily="34" charset="0"/>
+                <a:ea typeface="Arial" pitchFamily="34" charset="-122"/>
+                <a:cs typeface="Arial" pitchFamily="34" charset="-120"/>
+              </a:rPr>
+              <a:t>22</a:t>
+            </a:r>
+            <a:endParaRPr lang="en-US" sz="1000" dirty="0"/>
+          </a:p>
+        </p:txBody>
+      </p:sp>
+      <p:sp>
+        <p:nvSpPr>
+          <p:cNvPr id="75" name="Text 63"/>
+          <p:cNvSpPr/>
+          <p:nvPr/>
+        </p:nvSpPr>
+        <p:spPr>
+          <a:xfrm>
+            <a:off x="4191000" y="5041900"/>
+            <a:ext cx="508000" cy="330200"/>
+          </a:xfrm>
+          <a:prstGeom prst="rect">
+            <a:avLst/>
+          </a:prstGeom>
+          <a:noFill/>
+          <a:ln/>
+        </p:spPr>
+        <p:txBody>
+          <a:bodyPr wrap="square" lIns="0" tIns="0" rIns="0" bIns="0" rtlCol="0" anchor="ctr"/>
+          <a:lstStyle/>
+          <a:p>
+            <a:pPr algn="l" indent="0" marL="0">
+              <a:buNone/>
+            </a:pPr>
+            <a:r>
+              <a:rPr lang="en-US" sz="1000" i="1" dirty="0">
+                <a:solidFill>
+                  <a:srgbClr val="000000"/>
+                </a:solidFill>
+                <a:latin typeface="Arial" pitchFamily="34" charset="0"/>
+                <a:ea typeface="Arial" pitchFamily="34" charset="-122"/>
+                <a:cs typeface="Arial" pitchFamily="34" charset="-120"/>
+              </a:rPr>
+              <a:t>...</a:t>
+            </a:r>
+            <a:endParaRPr lang="en-US" sz="1000" dirty="0"/>
+          </a:p>
+        </p:txBody>
+      </p:sp>
+      <p:sp>
+        <p:nvSpPr>
+          <p:cNvPr id="76" name="Text 64"/>
+          <p:cNvSpPr/>
+          <p:nvPr/>
+        </p:nvSpPr>
+        <p:spPr>
+          <a:xfrm>
+            <a:off x="4635500" y="5041900"/>
+            <a:ext cx="508000" cy="330200"/>
+          </a:xfrm>
+          <a:prstGeom prst="rect">
+            <a:avLst/>
+          </a:prstGeom>
+          <a:noFill/>
+          <a:ln/>
+        </p:spPr>
+        <p:txBody>
+          <a:bodyPr wrap="square" lIns="0" tIns="0" rIns="0" bIns="0" rtlCol="0" anchor="ctr"/>
+          <a:lstStyle/>
+          <a:p>
+            <a:pPr algn="l" indent="0" marL="0">
+              <a:buNone/>
+            </a:pPr>
+            <a:r>
+              <a:rPr lang="en-US" sz="1000" i="1" dirty="0">
+                <a:solidFill>
+                  <a:srgbClr val="000000"/>
+                </a:solidFill>
+                <a:latin typeface="Arial" pitchFamily="34" charset="0"/>
+                <a:ea typeface="Arial" pitchFamily="34" charset="-122"/>
+                <a:cs typeface="Arial" pitchFamily="34" charset="-120"/>
+              </a:rPr>
+              <a:t>x</a:t>
+            </a:r>
+            <a:pPr algn="l" indent="0" marL="0">
+              <a:buNone/>
+            </a:pPr>
+            <a:r>
+              <a:rPr lang="en-US" sz="1000" i="1" baseline="-40000" dirty="0">
+                <a:solidFill>
+                  <a:srgbClr val="000000"/>
+                </a:solidFill>
+                <a:latin typeface="Arial" pitchFamily="34" charset="0"/>
+                <a:ea typeface="Arial" pitchFamily="34" charset="-122"/>
+                <a:cs typeface="Arial" pitchFamily="34" charset="-120"/>
+              </a:rPr>
+              <a:t>2d</a:t>
+            </a:r>
+            <a:endParaRPr lang="en-US" sz="1000" dirty="0"/>
+          </a:p>
+        </p:txBody>
+      </p:sp>
+      <p:sp>
+        <p:nvSpPr>
+          <p:cNvPr id="77" name="Text 65"/>
+          <p:cNvSpPr/>
+          <p:nvPr/>
+        </p:nvSpPr>
+        <p:spPr>
+          <a:xfrm>
+            <a:off x="2654300" y="5422900"/>
+            <a:ext cx="508000" cy="317500"/>
+          </a:xfrm>
+          <a:prstGeom prst="rect">
+            <a:avLst/>
+          </a:prstGeom>
+          <a:noFill/>
+          <a:ln/>
+        </p:spPr>
+        <p:txBody>
+          <a:bodyPr wrap="square" lIns="0" tIns="0" rIns="0" bIns="0" rtlCol="0" anchor="ctr"/>
+          <a:lstStyle/>
+          <a:p>
+            <a:pPr algn="l" indent="0" marL="0">
+              <a:buNone/>
+            </a:pPr>
+            <a:r>
+              <a:rPr lang="en-US" sz="1000" i="1" dirty="0">
+                <a:solidFill>
+                  <a:srgbClr val="000000"/>
+                </a:solidFill>
+                <a:latin typeface="Arial" pitchFamily="34" charset="0"/>
+                <a:ea typeface="Arial" pitchFamily="34" charset="-122"/>
+                <a:cs typeface="Arial" pitchFamily="34" charset="-120"/>
+              </a:rPr>
+              <a:t>1</a:t>
+            </a:r>
+            <a:endParaRPr lang="en-US" sz="1000" dirty="0"/>
+          </a:p>
+        </p:txBody>
+      </p:sp>
+      <p:sp>
+        <p:nvSpPr>
+          <p:cNvPr id="78" name="Text 66"/>
+          <p:cNvSpPr/>
+          <p:nvPr/>
+        </p:nvSpPr>
+        <p:spPr>
+          <a:xfrm>
+            <a:off x="3111500" y="5422900"/>
+            <a:ext cx="508000" cy="317500"/>
+          </a:xfrm>
+          <a:prstGeom prst="rect">
+            <a:avLst/>
+          </a:prstGeom>
+          <a:noFill/>
+          <a:ln/>
+        </p:spPr>
+        <p:txBody>
+          <a:bodyPr wrap="square" lIns="0" tIns="0" rIns="0" bIns="0" rtlCol="0" anchor="ctr"/>
+          <a:lstStyle/>
+          <a:p>
+            <a:pPr algn="l" indent="0" marL="0">
+              <a:buNone/>
+            </a:pPr>
+            <a:r>
+              <a:rPr lang="en-US" sz="1000" i="1" dirty="0">
+                <a:solidFill>
+                  <a:srgbClr val="000000"/>
+                </a:solidFill>
+                <a:latin typeface="Arial" pitchFamily="34" charset="0"/>
+                <a:ea typeface="Arial" pitchFamily="34" charset="-122"/>
+                <a:cs typeface="Arial" pitchFamily="34" charset="-120"/>
+              </a:rPr>
+              <a:t>...</a:t>
+            </a:r>
+            <a:endParaRPr lang="en-US" sz="1000" dirty="0"/>
+          </a:p>
+        </p:txBody>
+      </p:sp>
+      <p:sp>
+        <p:nvSpPr>
+          <p:cNvPr id="79" name="Text 67"/>
+          <p:cNvSpPr/>
+          <p:nvPr/>
+        </p:nvSpPr>
+        <p:spPr>
+          <a:xfrm>
+            <a:off x="3683000" y="5422900"/>
+            <a:ext cx="508000" cy="317500"/>
+          </a:xfrm>
+          <a:prstGeom prst="rect">
+            <a:avLst/>
+          </a:prstGeom>
+          <a:noFill/>
+          <a:ln/>
+        </p:spPr>
+        <p:txBody>
+          <a:bodyPr wrap="square" lIns="0" tIns="0" rIns="0" bIns="0" rtlCol="0" anchor="ctr"/>
+          <a:lstStyle/>
+          <a:p>
+            <a:pPr algn="l" indent="0" marL="0">
+              <a:buNone/>
+            </a:pPr>
+            <a:r>
+              <a:rPr lang="en-US" sz="1000" i="1" dirty="0">
+                <a:solidFill>
+                  <a:srgbClr val="000000"/>
+                </a:solidFill>
+                <a:latin typeface="Arial" pitchFamily="34" charset="0"/>
+                <a:ea typeface="Arial" pitchFamily="34" charset="-122"/>
+                <a:cs typeface="Arial" pitchFamily="34" charset="-120"/>
+              </a:rPr>
+              <a:t>...</a:t>
+            </a:r>
+            <a:endParaRPr lang="en-US" sz="1000" dirty="0"/>
+          </a:p>
+        </p:txBody>
+      </p:sp>
+      <p:sp>
+        <p:nvSpPr>
+          <p:cNvPr id="80" name="Text 68"/>
+          <p:cNvSpPr/>
+          <p:nvPr/>
+        </p:nvSpPr>
+        <p:spPr>
+          <a:xfrm>
+            <a:off x="4191000" y="5422900"/>
+            <a:ext cx="508000" cy="317500"/>
+          </a:xfrm>
+          <a:prstGeom prst="rect">
+            <a:avLst/>
+          </a:prstGeom>
+          <a:noFill/>
+          <a:ln/>
+        </p:spPr>
+        <p:txBody>
+          <a:bodyPr wrap="square" lIns="0" tIns="0" rIns="0" bIns="0" rtlCol="0" anchor="ctr"/>
+          <a:lstStyle/>
+          <a:p>
+            <a:pPr algn="l" indent="0" marL="0">
+              <a:buNone/>
+            </a:pPr>
+            <a:r>
+              <a:rPr lang="en-US" sz="1000" i="1" dirty="0">
+                <a:solidFill>
+                  <a:srgbClr val="000000"/>
+                </a:solidFill>
+                <a:latin typeface="Arial" pitchFamily="34" charset="0"/>
+                <a:ea typeface="Arial" pitchFamily="34" charset="-122"/>
+                <a:cs typeface="Arial" pitchFamily="34" charset="-120"/>
+              </a:rPr>
+              <a:t>...</a:t>
+            </a:r>
+            <a:endParaRPr lang="en-US" sz="1000" dirty="0"/>
+          </a:p>
+        </p:txBody>
+      </p:sp>
+      <p:sp>
+        <p:nvSpPr>
+          <p:cNvPr id="81" name="Text 69"/>
+          <p:cNvSpPr/>
+          <p:nvPr/>
+        </p:nvSpPr>
+        <p:spPr>
+          <a:xfrm>
+            <a:off x="4635500" y="5422900"/>
+            <a:ext cx="508000" cy="317500"/>
+          </a:xfrm>
+          <a:prstGeom prst="rect">
+            <a:avLst/>
+          </a:prstGeom>
+          <a:noFill/>
+          <a:ln/>
+        </p:spPr>
+        <p:txBody>
+          <a:bodyPr wrap="square" lIns="0" tIns="0" rIns="0" bIns="0" rtlCol="0" anchor="ctr"/>
+          <a:lstStyle/>
+          <a:p>
+            <a:pPr algn="l" indent="0" marL="0">
+              <a:buNone/>
+            </a:pPr>
+            <a:r>
+              <a:rPr lang="en-US" sz="1000" i="1" dirty="0">
+                <a:solidFill>
+                  <a:srgbClr val="000000"/>
+                </a:solidFill>
+                <a:latin typeface="Arial" pitchFamily="34" charset="0"/>
+                <a:ea typeface="Arial" pitchFamily="34" charset="-122"/>
+                <a:cs typeface="Arial" pitchFamily="34" charset="-120"/>
+              </a:rPr>
+              <a:t>...</a:t>
+            </a:r>
+            <a:endParaRPr lang="en-US" sz="1000" dirty="0"/>
+          </a:p>
+        </p:txBody>
+      </p:sp>
+      <p:sp>
+        <p:nvSpPr>
+          <p:cNvPr id="82" name="Text 70"/>
+          <p:cNvSpPr/>
+          <p:nvPr/>
+        </p:nvSpPr>
+        <p:spPr>
+          <a:xfrm>
+            <a:off x="2654300" y="5791200"/>
+            <a:ext cx="508000" cy="279400"/>
+          </a:xfrm>
+          <a:prstGeom prst="rect">
+            <a:avLst/>
+          </a:prstGeom>
+          <a:noFill/>
+          <a:ln/>
+        </p:spPr>
+        <p:txBody>
+          <a:bodyPr wrap="square" lIns="0" tIns="0" rIns="0" bIns="0" rtlCol="0" anchor="ctr"/>
+          <a:lstStyle/>
+          <a:p>
+            <a:pPr algn="l" indent="0" marL="0">
+              <a:buNone/>
+            </a:pPr>
+            <a:r>
+              <a:rPr lang="en-US" sz="1000" i="1" dirty="0">
+                <a:solidFill>
+                  <a:srgbClr val="000000"/>
+                </a:solidFill>
+                <a:latin typeface="Arial" pitchFamily="34" charset="0"/>
+                <a:ea typeface="Arial" pitchFamily="34" charset="-122"/>
+                <a:cs typeface="Arial" pitchFamily="34" charset="-120"/>
+              </a:rPr>
+              <a:t>1</a:t>
+            </a:r>
+            <a:endParaRPr lang="en-US" sz="1000" dirty="0"/>
+          </a:p>
+        </p:txBody>
+      </p:sp>
+      <p:sp>
+        <p:nvSpPr>
+          <p:cNvPr id="83" name="Text 71"/>
+          <p:cNvSpPr/>
+          <p:nvPr/>
+        </p:nvSpPr>
+        <p:spPr>
+          <a:xfrm>
+            <a:off x="3111500" y="5791200"/>
+            <a:ext cx="508000" cy="279400"/>
+          </a:xfrm>
+          <a:prstGeom prst="rect">
+            <a:avLst/>
+          </a:prstGeom>
+          <a:noFill/>
+          <a:ln/>
+        </p:spPr>
+        <p:txBody>
+          <a:bodyPr wrap="square" lIns="0" tIns="0" rIns="0" bIns="0" rtlCol="0" anchor="ctr"/>
+          <a:lstStyle/>
+          <a:p>
+            <a:pPr algn="l" indent="0" marL="0">
+              <a:buNone/>
+            </a:pPr>
+            <a:r>
+              <a:rPr lang="en-US" sz="1000" i="1" dirty="0">
+                <a:solidFill>
+                  <a:srgbClr val="000000"/>
+                </a:solidFill>
+                <a:latin typeface="Arial" pitchFamily="34" charset="0"/>
+                <a:ea typeface="Arial" pitchFamily="34" charset="-122"/>
+                <a:cs typeface="Arial" pitchFamily="34" charset="-120"/>
+              </a:rPr>
+              <a:t>x</a:t>
+            </a:r>
+            <a:pPr algn="l" indent="0" marL="0">
+              <a:buNone/>
+            </a:pPr>
+            <a:r>
+              <a:rPr lang="en-US" sz="1000" i="1" baseline="-40000" dirty="0">
+                <a:solidFill>
+                  <a:srgbClr val="000000"/>
+                </a:solidFill>
+                <a:latin typeface="Arial" pitchFamily="34" charset="0"/>
+                <a:ea typeface="Arial" pitchFamily="34" charset="-122"/>
+                <a:cs typeface="Arial" pitchFamily="34" charset="-120"/>
+              </a:rPr>
+              <a:t>n1</a:t>
+            </a:r>
+            <a:endParaRPr lang="en-US" sz="1000" dirty="0"/>
+          </a:p>
+        </p:txBody>
+      </p:sp>
+      <p:sp>
+        <p:nvSpPr>
+          <p:cNvPr id="84" name="Text 72"/>
+          <p:cNvSpPr/>
+          <p:nvPr/>
+        </p:nvSpPr>
+        <p:spPr>
+          <a:xfrm>
+            <a:off x="3683000" y="5791200"/>
+            <a:ext cx="508000" cy="279400"/>
+          </a:xfrm>
+          <a:prstGeom prst="rect">
+            <a:avLst/>
+          </a:prstGeom>
+          <a:noFill/>
+          <a:ln/>
+        </p:spPr>
+        <p:txBody>
+          <a:bodyPr wrap="square" lIns="0" tIns="0" rIns="0" bIns="0" rtlCol="0" anchor="ctr"/>
+          <a:lstStyle/>
+          <a:p>
+            <a:pPr algn="l" indent="0" marL="0">
+              <a:buNone/>
+            </a:pPr>
+            <a:r>
+              <a:rPr lang="en-US" sz="1000" i="1" dirty="0">
+                <a:solidFill>
+                  <a:srgbClr val="000000"/>
+                </a:solidFill>
+                <a:latin typeface="Arial" pitchFamily="34" charset="0"/>
+                <a:ea typeface="Arial" pitchFamily="34" charset="-122"/>
+                <a:cs typeface="Arial" pitchFamily="34" charset="-120"/>
+              </a:rPr>
+              <a:t>x</a:t>
+            </a:r>
+            <a:pPr algn="l" indent="0" marL="0">
+              <a:buNone/>
+            </a:pPr>
+            <a:r>
+              <a:rPr lang="en-US" sz="1000" i="1" baseline="-40000" dirty="0">
+                <a:solidFill>
+                  <a:srgbClr val="000000"/>
+                </a:solidFill>
+                <a:latin typeface="Arial" pitchFamily="34" charset="0"/>
+                <a:ea typeface="Arial" pitchFamily="34" charset="-122"/>
+                <a:cs typeface="Arial" pitchFamily="34" charset="-120"/>
+              </a:rPr>
+              <a:t>n2</a:t>
+            </a:r>
+            <a:endParaRPr lang="en-US" sz="1000" dirty="0"/>
+          </a:p>
+        </p:txBody>
+      </p:sp>
+      <p:sp>
+        <p:nvSpPr>
+          <p:cNvPr id="85" name="Text 73"/>
+          <p:cNvSpPr/>
+          <p:nvPr/>
+        </p:nvSpPr>
+        <p:spPr>
+          <a:xfrm>
+            <a:off x="4191000" y="5791200"/>
+            <a:ext cx="508000" cy="279400"/>
+          </a:xfrm>
+          <a:prstGeom prst="rect">
+            <a:avLst/>
+          </a:prstGeom>
+          <a:noFill/>
+          <a:ln/>
+        </p:spPr>
+        <p:txBody>
+          <a:bodyPr wrap="square" lIns="0" tIns="0" rIns="0" bIns="0" rtlCol="0" anchor="ctr"/>
+          <a:lstStyle/>
+          <a:p>
+            <a:pPr algn="l" indent="0" marL="0">
+              <a:buNone/>
+            </a:pPr>
+            <a:r>
+              <a:rPr lang="en-US" sz="1000" i="1" dirty="0">
+                <a:solidFill>
+                  <a:srgbClr val="000000"/>
+                </a:solidFill>
+                <a:latin typeface="Arial" pitchFamily="34" charset="0"/>
+                <a:ea typeface="Arial" pitchFamily="34" charset="-122"/>
+                <a:cs typeface="Arial" pitchFamily="34" charset="-120"/>
+              </a:rPr>
+              <a:t>...</a:t>
+            </a:r>
+            <a:endParaRPr lang="en-US" sz="1000" dirty="0"/>
+          </a:p>
+        </p:txBody>
+      </p:sp>
+      <p:sp>
+        <p:nvSpPr>
+          <p:cNvPr id="86" name="Text 74"/>
+          <p:cNvSpPr/>
+          <p:nvPr/>
+        </p:nvSpPr>
+        <p:spPr>
+          <a:xfrm>
+            <a:off x="4635500" y="5791200"/>
+            <a:ext cx="508000" cy="279400"/>
+          </a:xfrm>
+          <a:prstGeom prst="rect">
+            <a:avLst/>
+          </a:prstGeom>
+          <a:noFill/>
+          <a:ln/>
+        </p:spPr>
+        <p:txBody>
+          <a:bodyPr wrap="square" lIns="0" tIns="0" rIns="0" bIns="0" rtlCol="0" anchor="ctr"/>
+          <a:lstStyle/>
+          <a:p>
+            <a:pPr algn="l" indent="0" marL="0">
+              <a:buNone/>
+            </a:pPr>
+            <a:r>
+              <a:rPr lang="en-US" sz="1000" i="1" dirty="0">
+                <a:solidFill>
+                  <a:srgbClr val="000000"/>
+                </a:solidFill>
+                <a:latin typeface="Arial" pitchFamily="34" charset="0"/>
+                <a:ea typeface="Arial" pitchFamily="34" charset="-122"/>
+                <a:cs typeface="Arial" pitchFamily="34" charset="-120"/>
+              </a:rPr>
+              <a:t>x</a:t>
+            </a:r>
+            <a:pPr algn="l" indent="0" marL="0">
+              <a:buNone/>
+            </a:pPr>
+            <a:r>
+              <a:rPr lang="en-US" sz="1000" i="1" baseline="-40000" dirty="0">
+                <a:solidFill>
+                  <a:srgbClr val="000000"/>
+                </a:solidFill>
+                <a:latin typeface="Arial" pitchFamily="34" charset="0"/>
+                <a:ea typeface="Arial" pitchFamily="34" charset="-122"/>
+                <a:cs typeface="Arial" pitchFamily="34" charset="-120"/>
+              </a:rPr>
+              <a:t>nd</a:t>
+            </a:r>
+            <a:endParaRPr lang="en-US" sz="1000" dirty="0"/>
+          </a:p>
+        </p:txBody>
+      </p:sp>
+      <p:pic>
+        <p:nvPicPr>
+          <p:cNvPr id="87" name="Image 10" descr="/home/ahmed/Projects/ai_llm_slides/videos/machine-learning/03_ridger_regression_gradient_descent/recreated_pptx/qa/slide003/parens/arc_matrix_L.png">    </p:cNvPr>
+          <p:cNvPicPr>
+            <a:picLocks noChangeAspect="1"/>
+          </p:cNvPicPr>
+          <p:nvPr/>
+        </p:nvPicPr>
+        <p:blipFill>
+          <a:blip r:embed="rId11"/>
+          <a:stretch>
+            <a:fillRect/>
+          </a:stretch>
+        </p:blipFill>
+        <p:spPr>
+          <a:xfrm>
+            <a:off x="2463800" y="4597400"/>
+            <a:ext cx="48260" cy="1549400"/>
+          </a:xfrm>
+          <a:prstGeom prst="rect">
+            <a:avLst/>
+          </a:prstGeom>
+        </p:spPr>
+      </p:pic>
+      <p:pic>
+        <p:nvPicPr>
+          <p:cNvPr id="88" name="Image 11" descr="/home/ahmed/Projects/ai_llm_slides/videos/machine-learning/03_ridger_regression_gradient_descent/recreated_pptx/qa/slide003/parens/arc_matrix_R.png">    </p:cNvPr>
+          <p:cNvPicPr>
+            <a:picLocks noChangeAspect="1"/>
+          </p:cNvPicPr>
+          <p:nvPr/>
+        </p:nvPicPr>
+        <p:blipFill>
+          <a:blip r:embed="rId12"/>
+          <a:stretch>
+            <a:fillRect/>
+          </a:stretch>
+        </p:blipFill>
+        <p:spPr>
+          <a:xfrm>
+            <a:off x="4927600" y="4597400"/>
+            <a:ext cx="48260" cy="1549400"/>
+          </a:xfrm>
+          <a:prstGeom prst="rect">
+            <a:avLst/>
+          </a:prstGeom>
+        </p:spPr>
+      </p:pic>
+      <p:sp>
+        <p:nvSpPr>
+          <p:cNvPr id="89" name="Shape 75"/>
+          <p:cNvSpPr/>
+          <p:nvPr/>
+        </p:nvSpPr>
+        <p:spPr>
+          <a:xfrm>
+            <a:off x="2520950" y="4648200"/>
+            <a:ext cx="0" cy="1409700"/>
+          </a:xfrm>
+          <a:prstGeom prst="line">
+            <a:avLst/>
+          </a:prstGeom>
+          <a:noFill/>
+          <a:ln w="9525">
             <a:solidFill>
               <a:srgbClr val="000000"/>
             </a:solidFill>
@@ -2873,19 +4363,20 @@
       </p:sp>
       <p:sp>
         <p:nvSpPr>
-          <p:cNvPr id="53" name="Shape 51"/>
-          <p:cNvSpPr/>
-          <p:nvPr/>
-        </p:nvSpPr>
-        <p:spPr>
-          <a:xfrm>
-            <a:off x="1397000" y="4241800"/>
-            <a:ext cx="114300" cy="1778000"/>
-          </a:xfrm>
-          <a:prstGeom prst="rightBracket">
-            <a:avLst/>
-          </a:prstGeom>
-          <a:ln w="12700">
+          <p:cNvPr id="90" name="Shape 76"/>
+          <p:cNvSpPr/>
+          <p:nvPr/>
+        </p:nvSpPr>
+        <p:spPr>
+          <a:xfrm>
+            <a:off x="5010150" y="4648200"/>
+            <a:ext cx="0" cy="1409700"/>
+          </a:xfrm>
+          <a:prstGeom prst="line">
+            <a:avLst/>
+          </a:prstGeom>
+          <a:noFill/>
+          <a:ln w="9525">
             <a:solidFill>
               <a:srgbClr val="000000"/>
             </a:solidFill>
@@ -2895,1310 +4386,94 @@
       </p:sp>
       <p:sp>
         <p:nvSpPr>
-          <p:cNvPr id="54" name="Text 52"/>
-          <p:cNvSpPr/>
-          <p:nvPr/>
-        </p:nvSpPr>
-        <p:spPr>
-          <a:xfrm>
-            <a:off x="1066800" y="4292600"/>
-            <a:ext cx="431800" cy="279400"/>
-          </a:xfrm>
-          <a:prstGeom prst="rect">
-            <a:avLst/>
-          </a:prstGeom>
-          <a:noFill/>
-          <a:ln/>
-        </p:spPr>
-        <p:txBody>
-          <a:bodyPr wrap="square" lIns="0" tIns="0" rIns="0" bIns="0" rtlCol="0" anchor="ctr"/>
-          <a:lstStyle/>
-          <a:p>
-            <a:pPr algn="ctr" indent="0" marL="0">
-              <a:buNone/>
-            </a:pPr>
-            <a:r>
-              <a:rPr lang="en-US" sz="1100" i="1" dirty="0">
-                <a:solidFill>
-                  <a:srgbClr val="000000"/>
-                </a:solidFill>
-                <a:latin typeface="Arial" pitchFamily="34" charset="0"/>
-                <a:ea typeface="Arial" pitchFamily="34" charset="-122"/>
-                <a:cs typeface="Arial" pitchFamily="34" charset="-120"/>
-              </a:rPr>
-              <a:t>y</a:t>
-            </a:r>
-            <a:pPr algn="ctr" indent="0" marL="0">
-              <a:buNone/>
-            </a:pPr>
-            <a:r>
-              <a:rPr lang="en-US" sz="1100" i="1" baseline="-40000" dirty="0">
-                <a:solidFill>
-                  <a:srgbClr val="000000"/>
-                </a:solidFill>
-                <a:latin typeface="Arial" pitchFamily="34" charset="0"/>
-                <a:ea typeface="Arial" pitchFamily="34" charset="-122"/>
-                <a:cs typeface="Arial" pitchFamily="34" charset="-120"/>
-              </a:rPr>
-              <a:t>1</a:t>
+          <p:cNvPr id="91" name="Text 77"/>
+          <p:cNvSpPr/>
+          <p:nvPr/>
+        </p:nvSpPr>
+        <p:spPr>
+          <a:xfrm>
+            <a:off x="5067300" y="5943600"/>
+            <a:ext cx="1397000" cy="254000"/>
+          </a:xfrm>
+          <a:prstGeom prst="rect">
+            <a:avLst/>
+          </a:prstGeom>
+          <a:noFill/>
+          <a:ln/>
+        </p:spPr>
+        <p:txBody>
+          <a:bodyPr wrap="square" lIns="0" tIns="0" rIns="0" bIns="0" rtlCol="0" anchor="t"/>
+          <a:lstStyle/>
+          <a:p>
+            <a:pPr algn="l" indent="0" marL="0">
+              <a:buNone/>
+            </a:pPr>
+            <a:r>
+              <a:rPr lang="en-US" sz="1100" b="1" dirty="0">
+                <a:solidFill>
+                  <a:srgbClr val="333333"/>
+                </a:solidFill>
+                <a:latin typeface="Arial" pitchFamily="34" charset="0"/>
+                <a:ea typeface="Arial" pitchFamily="34" charset="-122"/>
+                <a:cs typeface="Arial" pitchFamily="34" charset="-120"/>
+              </a:rPr>
+              <a:t>N × d+1</a:t>
             </a:r>
             <a:endParaRPr lang="en-US" sz="1100" dirty="0"/>
           </a:p>
         </p:txBody>
       </p:sp>
-      <p:sp>
-        <p:nvSpPr>
-          <p:cNvPr id="55" name="Text 53"/>
-          <p:cNvSpPr/>
-          <p:nvPr/>
-        </p:nvSpPr>
-        <p:spPr>
-          <a:xfrm>
-            <a:off x="1066800" y="4749800"/>
-            <a:ext cx="431800" cy="279400"/>
-          </a:xfrm>
-          <a:prstGeom prst="rect">
-            <a:avLst/>
-          </a:prstGeom>
-          <a:noFill/>
-          <a:ln/>
-        </p:spPr>
-        <p:txBody>
-          <a:bodyPr wrap="square" lIns="0" tIns="0" rIns="0" bIns="0" rtlCol="0" anchor="ctr"/>
-          <a:lstStyle/>
-          <a:p>
-            <a:pPr algn="ctr" indent="0" marL="0">
-              <a:buNone/>
-            </a:pPr>
-            <a:r>
-              <a:rPr lang="en-US" sz="1100" i="1" dirty="0">
-                <a:solidFill>
-                  <a:srgbClr val="000000"/>
-                </a:solidFill>
-                <a:latin typeface="Arial" pitchFamily="34" charset="0"/>
-                <a:ea typeface="Arial" pitchFamily="34" charset="-122"/>
-                <a:cs typeface="Arial" pitchFamily="34" charset="-120"/>
-              </a:rPr>
-              <a:t>y</a:t>
-            </a:r>
-            <a:pPr algn="ctr" indent="0" marL="0">
-              <a:buNone/>
-            </a:pPr>
-            <a:r>
-              <a:rPr lang="en-US" sz="1100" i="1" baseline="-40000" dirty="0">
-                <a:solidFill>
-                  <a:srgbClr val="000000"/>
-                </a:solidFill>
-                <a:latin typeface="Arial" pitchFamily="34" charset="0"/>
-                <a:ea typeface="Arial" pitchFamily="34" charset="-122"/>
-                <a:cs typeface="Arial" pitchFamily="34" charset="-120"/>
-              </a:rPr>
-              <a:t>2</a:t>
-            </a:r>
-            <a:endParaRPr lang="en-US" sz="1100" dirty="0"/>
-          </a:p>
-        </p:txBody>
-      </p:sp>
-      <p:sp>
-        <p:nvSpPr>
-          <p:cNvPr id="56" name="Text 54"/>
-          <p:cNvSpPr/>
-          <p:nvPr/>
-        </p:nvSpPr>
-        <p:spPr>
-          <a:xfrm>
-            <a:off x="1066800" y="5207000"/>
-            <a:ext cx="431800" cy="279400"/>
-          </a:xfrm>
-          <a:prstGeom prst="rect">
-            <a:avLst/>
-          </a:prstGeom>
-          <a:noFill/>
-          <a:ln/>
-        </p:spPr>
-        <p:txBody>
-          <a:bodyPr wrap="square" lIns="0" tIns="0" rIns="0" bIns="0" rtlCol="0" anchor="ctr"/>
-          <a:lstStyle/>
-          <a:p>
-            <a:pPr algn="ctr" indent="0" marL="0">
-              <a:buNone/>
-            </a:pPr>
-            <a:r>
-              <a:rPr lang="en-US" sz="1100" i="1" dirty="0">
-                <a:solidFill>
-                  <a:srgbClr val="000000"/>
-                </a:solidFill>
-                <a:latin typeface="Arial" pitchFamily="34" charset="0"/>
-                <a:ea typeface="Arial" pitchFamily="34" charset="-122"/>
-                <a:cs typeface="Arial" pitchFamily="34" charset="-120"/>
-              </a:rPr>
-              <a:t>y</a:t>
-            </a:r>
-            <a:endParaRPr lang="en-US" sz="1100" dirty="0"/>
-          </a:p>
-        </p:txBody>
-      </p:sp>
-      <p:sp>
-        <p:nvSpPr>
-          <p:cNvPr id="57" name="Text 55"/>
-          <p:cNvSpPr/>
-          <p:nvPr/>
-        </p:nvSpPr>
-        <p:spPr>
-          <a:xfrm>
-            <a:off x="1066800" y="5664200"/>
-            <a:ext cx="431800" cy="279400"/>
-          </a:xfrm>
-          <a:prstGeom prst="rect">
-            <a:avLst/>
-          </a:prstGeom>
-          <a:noFill/>
-          <a:ln/>
-        </p:spPr>
-        <p:txBody>
-          <a:bodyPr wrap="square" lIns="0" tIns="0" rIns="0" bIns="0" rtlCol="0" anchor="ctr"/>
-          <a:lstStyle/>
-          <a:p>
-            <a:pPr algn="ctr" indent="0" marL="0">
-              <a:buNone/>
-            </a:pPr>
-            <a:r>
-              <a:rPr lang="en-US" sz="1100" i="1" dirty="0">
-                <a:solidFill>
-                  <a:srgbClr val="000000"/>
-                </a:solidFill>
-                <a:latin typeface="Arial" pitchFamily="34" charset="0"/>
-                <a:ea typeface="Arial" pitchFamily="34" charset="-122"/>
-                <a:cs typeface="Arial" pitchFamily="34" charset="-120"/>
-              </a:rPr>
-              <a:t>y</a:t>
-            </a:r>
-            <a:pPr algn="ctr" indent="0" marL="0">
-              <a:buNone/>
-            </a:pPr>
-            <a:r>
-              <a:rPr lang="en-US" sz="1100" i="1" baseline="-40000" dirty="0">
-                <a:solidFill>
-                  <a:srgbClr val="000000"/>
-                </a:solidFill>
-                <a:latin typeface="Arial" pitchFamily="34" charset="0"/>
-                <a:ea typeface="Arial" pitchFamily="34" charset="-122"/>
-                <a:cs typeface="Arial" pitchFamily="34" charset="-120"/>
-              </a:rPr>
-              <a:t>n</a:t>
-            </a:r>
-            <a:endParaRPr lang="en-US" sz="1100" dirty="0"/>
-          </a:p>
-        </p:txBody>
-      </p:sp>
-      <p:sp>
-        <p:nvSpPr>
-          <p:cNvPr id="58" name="Text 56"/>
-          <p:cNvSpPr/>
-          <p:nvPr/>
-        </p:nvSpPr>
-        <p:spPr>
-          <a:xfrm>
-            <a:off x="1092200" y="6019800"/>
-            <a:ext cx="1016000" cy="228600"/>
-          </a:xfrm>
-          <a:prstGeom prst="rect">
-            <a:avLst/>
-          </a:prstGeom>
-          <a:noFill/>
-          <a:ln/>
-        </p:spPr>
-        <p:txBody>
-          <a:bodyPr wrap="square" lIns="0" tIns="0" rIns="0" bIns="0" rtlCol="0" anchor="t"/>
-          <a:lstStyle/>
-          <a:p>
-            <a:pPr algn="ctr" indent="0" marL="0">
-              <a:buNone/>
-            </a:pPr>
-            <a:r>
-              <a:rPr lang="en-US" sz="1100" b="1" dirty="0">
-                <a:solidFill>
-                  <a:srgbClr val="FF0000"/>
-                </a:solidFill>
-                <a:latin typeface="Arial" pitchFamily="34" charset="0"/>
-                <a:ea typeface="Arial" pitchFamily="34" charset="-122"/>
-                <a:cs typeface="Arial" pitchFamily="34" charset="-120"/>
-              </a:rPr>
-              <a:t>N × 1</a:t>
-            </a:r>
-            <a:endParaRPr lang="en-US" sz="1100" dirty="0"/>
-          </a:p>
-        </p:txBody>
-      </p:sp>
-      <p:sp>
-        <p:nvSpPr>
-          <p:cNvPr id="59" name="Text 57"/>
-          <p:cNvSpPr/>
-          <p:nvPr/>
-        </p:nvSpPr>
-        <p:spPr>
-          <a:xfrm>
-            <a:off x="1600200" y="4876800"/>
-            <a:ext cx="304800" cy="381000"/>
-          </a:xfrm>
-          <a:prstGeom prst="rect">
-            <a:avLst/>
-          </a:prstGeom>
-          <a:noFill/>
-          <a:ln/>
-        </p:spPr>
-        <p:txBody>
-          <a:bodyPr wrap="square" lIns="0" tIns="0" rIns="0" bIns="0" rtlCol="0" anchor="ctr"/>
-          <a:lstStyle/>
-          <a:p>
-            <a:pPr algn="ctr" indent="0" marL="0">
-              <a:buNone/>
-            </a:pPr>
-            <a:r>
-              <a:rPr lang="en-US" sz="2400" b="1" dirty="0">
-                <a:solidFill>
-                  <a:srgbClr val="000000"/>
-                </a:solidFill>
-                <a:latin typeface="Arial" pitchFamily="34" charset="0"/>
-                <a:ea typeface="Arial" pitchFamily="34" charset="-122"/>
-                <a:cs typeface="Arial" pitchFamily="34" charset="-120"/>
-              </a:rPr>
-              <a:t>=</a:t>
-            </a:r>
-            <a:endParaRPr lang="en-US" sz="2400" dirty="0"/>
-          </a:p>
-        </p:txBody>
-      </p:sp>
-      <p:sp>
-        <p:nvSpPr>
-          <p:cNvPr id="60" name="Shape 58"/>
-          <p:cNvSpPr/>
-          <p:nvPr/>
-        </p:nvSpPr>
-        <p:spPr>
-          <a:xfrm>
-            <a:off x="1905000" y="4673600"/>
-            <a:ext cx="3581400" cy="279400"/>
-          </a:xfrm>
-          <a:prstGeom prst="rect">
-            <a:avLst/>
-          </a:prstGeom>
-          <a:solidFill>
-            <a:srgbClr val="FFFF99"/>
-          </a:solidFill>
-          <a:ln/>
-        </p:spPr>
-      </p:sp>
-      <p:sp>
-        <p:nvSpPr>
-          <p:cNvPr id="61" name="Text 59"/>
-          <p:cNvSpPr/>
-          <p:nvPr/>
-        </p:nvSpPr>
-        <p:spPr>
-          <a:xfrm>
-            <a:off x="1955800" y="4673600"/>
-            <a:ext cx="508000" cy="279400"/>
-          </a:xfrm>
-          <a:prstGeom prst="rect">
-            <a:avLst/>
-          </a:prstGeom>
-          <a:noFill/>
-          <a:ln/>
-        </p:spPr>
-        <p:txBody>
-          <a:bodyPr wrap="square" lIns="0" tIns="0" rIns="0" bIns="0" rtlCol="0" anchor="ctr"/>
-          <a:lstStyle/>
-          <a:p>
-            <a:pPr algn="l" indent="0" marL="0">
-              <a:buNone/>
-            </a:pPr>
-            <a:endParaRPr lang="en-US" sz="1000" dirty="0"/>
-          </a:p>
-        </p:txBody>
-      </p:sp>
-      <p:sp>
-        <p:nvSpPr>
-          <p:cNvPr id="62" name="Text 60"/>
-          <p:cNvSpPr/>
-          <p:nvPr/>
-        </p:nvSpPr>
-        <p:spPr>
-          <a:xfrm>
-            <a:off x="2311400" y="4673600"/>
-            <a:ext cx="508000" cy="279400"/>
-          </a:xfrm>
-          <a:prstGeom prst="rect">
-            <a:avLst/>
-          </a:prstGeom>
-          <a:noFill/>
-          <a:ln/>
-        </p:spPr>
-        <p:txBody>
-          <a:bodyPr wrap="square" lIns="0" tIns="0" rIns="0" bIns="0" rtlCol="0" anchor="ctr"/>
-          <a:lstStyle/>
-          <a:p>
-            <a:pPr algn="l" indent="0" marL="0">
-              <a:buNone/>
-            </a:pPr>
-            <a:r>
-              <a:rPr lang="en-US" sz="1000" i="1" dirty="0">
-                <a:solidFill>
-                  <a:srgbClr val="000000"/>
-                </a:solidFill>
-                <a:latin typeface="Arial" pitchFamily="34" charset="0"/>
-                <a:ea typeface="Arial" pitchFamily="34" charset="-122"/>
-                <a:cs typeface="Arial" pitchFamily="34" charset="-120"/>
-              </a:rPr>
-              <a:t>x</a:t>
-            </a:r>
-            <a:pPr algn="l" indent="0" marL="0">
-              <a:buNone/>
-            </a:pPr>
-            <a:r>
-              <a:rPr lang="en-US" sz="1000" i="1" baseline="-40000" dirty="0">
-                <a:solidFill>
-                  <a:srgbClr val="000000"/>
-                </a:solidFill>
-                <a:latin typeface="Arial" pitchFamily="34" charset="0"/>
-                <a:ea typeface="Arial" pitchFamily="34" charset="-122"/>
-                <a:cs typeface="Arial" pitchFamily="34" charset="-120"/>
-              </a:rPr>
-              <a:t>11</a:t>
-            </a:r>
-            <a:endParaRPr lang="en-US" sz="1000" dirty="0"/>
-          </a:p>
-        </p:txBody>
-      </p:sp>
-      <p:sp>
-        <p:nvSpPr>
-          <p:cNvPr id="63" name="Text 61"/>
-          <p:cNvSpPr/>
-          <p:nvPr/>
-        </p:nvSpPr>
-        <p:spPr>
-          <a:xfrm>
-            <a:off x="2870200" y="4673600"/>
-            <a:ext cx="508000" cy="279400"/>
-          </a:xfrm>
-          <a:prstGeom prst="rect">
-            <a:avLst/>
-          </a:prstGeom>
-          <a:noFill/>
-          <a:ln/>
-        </p:spPr>
-        <p:txBody>
-          <a:bodyPr wrap="square" lIns="0" tIns="0" rIns="0" bIns="0" rtlCol="0" anchor="ctr"/>
-          <a:lstStyle/>
-          <a:p>
-            <a:pPr algn="l" indent="0" marL="0">
-              <a:buNone/>
-            </a:pPr>
-            <a:r>
-              <a:rPr lang="en-US" sz="1000" i="1" dirty="0">
-                <a:solidFill>
-                  <a:srgbClr val="000000"/>
-                </a:solidFill>
-                <a:latin typeface="Arial" pitchFamily="34" charset="0"/>
-                <a:ea typeface="Arial" pitchFamily="34" charset="-122"/>
-                <a:cs typeface="Arial" pitchFamily="34" charset="-120"/>
-              </a:rPr>
-              <a:t>x</a:t>
-            </a:r>
-            <a:pPr algn="l" indent="0" marL="0">
-              <a:buNone/>
-            </a:pPr>
-            <a:r>
-              <a:rPr lang="en-US" sz="1000" i="1" baseline="-40000" dirty="0">
-                <a:solidFill>
-                  <a:srgbClr val="000000"/>
-                </a:solidFill>
-                <a:latin typeface="Arial" pitchFamily="34" charset="0"/>
-                <a:ea typeface="Arial" pitchFamily="34" charset="-122"/>
-                <a:cs typeface="Arial" pitchFamily="34" charset="-120"/>
-              </a:rPr>
-              <a:t>12</a:t>
-            </a:r>
-            <a:endParaRPr lang="en-US" sz="1000" dirty="0"/>
-          </a:p>
-        </p:txBody>
-      </p:sp>
-      <p:sp>
-        <p:nvSpPr>
-          <p:cNvPr id="64" name="Text 62"/>
-          <p:cNvSpPr/>
-          <p:nvPr/>
-        </p:nvSpPr>
-        <p:spPr>
-          <a:xfrm>
-            <a:off x="3429000" y="4673600"/>
-            <a:ext cx="508000" cy="279400"/>
-          </a:xfrm>
-          <a:prstGeom prst="rect">
-            <a:avLst/>
-          </a:prstGeom>
-          <a:noFill/>
-          <a:ln/>
-        </p:spPr>
-        <p:txBody>
-          <a:bodyPr wrap="square" lIns="0" tIns="0" rIns="0" bIns="0" rtlCol="0" anchor="ctr"/>
-          <a:lstStyle/>
-          <a:p>
-            <a:pPr algn="l" indent="0" marL="0">
-              <a:buNone/>
-            </a:pPr>
-            <a:r>
-              <a:rPr lang="en-US" sz="1000" i="1" dirty="0">
-                <a:solidFill>
-                  <a:srgbClr val="000000"/>
-                </a:solidFill>
-                <a:latin typeface="Arial" pitchFamily="34" charset="0"/>
-                <a:ea typeface="Arial" pitchFamily="34" charset="-122"/>
-                <a:cs typeface="Arial" pitchFamily="34" charset="-120"/>
-              </a:rPr>
-              <a:t>...</a:t>
-            </a:r>
-            <a:endParaRPr lang="en-US" sz="1000" dirty="0"/>
-          </a:p>
-        </p:txBody>
-      </p:sp>
-      <p:sp>
-        <p:nvSpPr>
-          <p:cNvPr id="65" name="Text 63"/>
-          <p:cNvSpPr/>
-          <p:nvPr/>
-        </p:nvSpPr>
-        <p:spPr>
-          <a:xfrm>
-            <a:off x="3987800" y="4673600"/>
-            <a:ext cx="508000" cy="279400"/>
-          </a:xfrm>
-          <a:prstGeom prst="rect">
-            <a:avLst/>
-          </a:prstGeom>
-          <a:noFill/>
-          <a:ln/>
-        </p:spPr>
-        <p:txBody>
-          <a:bodyPr wrap="square" lIns="0" tIns="0" rIns="0" bIns="0" rtlCol="0" anchor="ctr"/>
-          <a:lstStyle/>
-          <a:p>
-            <a:pPr algn="l" indent="0" marL="0">
-              <a:buNone/>
-            </a:pPr>
-            <a:r>
-              <a:rPr lang="en-US" sz="1000" i="1" dirty="0">
-                <a:solidFill>
-                  <a:srgbClr val="000000"/>
-                </a:solidFill>
-                <a:latin typeface="Arial" pitchFamily="34" charset="0"/>
-                <a:ea typeface="Arial" pitchFamily="34" charset="-122"/>
-                <a:cs typeface="Arial" pitchFamily="34" charset="-120"/>
-              </a:rPr>
-              <a:t>x</a:t>
-            </a:r>
-            <a:pPr algn="l" indent="0" marL="0">
-              <a:buNone/>
-            </a:pPr>
-            <a:r>
-              <a:rPr lang="en-US" sz="1000" i="1" baseline="-40000" dirty="0">
-                <a:solidFill>
-                  <a:srgbClr val="000000"/>
-                </a:solidFill>
-                <a:latin typeface="Arial" pitchFamily="34" charset="0"/>
-                <a:ea typeface="Arial" pitchFamily="34" charset="-122"/>
-                <a:cs typeface="Arial" pitchFamily="34" charset="-120"/>
-              </a:rPr>
-              <a:t>1d</a:t>
-            </a:r>
-            <a:endParaRPr lang="en-US" sz="1000" dirty="0"/>
-          </a:p>
-        </p:txBody>
-      </p:sp>
-      <p:sp>
-        <p:nvSpPr>
-          <p:cNvPr id="66" name="Shape 64"/>
-          <p:cNvSpPr/>
-          <p:nvPr/>
-        </p:nvSpPr>
-        <p:spPr>
-          <a:xfrm>
-            <a:off x="1905000" y="5041900"/>
-            <a:ext cx="3581400" cy="330200"/>
-          </a:xfrm>
-          <a:prstGeom prst="rect">
-            <a:avLst/>
-          </a:prstGeom>
-          <a:solidFill>
-            <a:srgbClr val="CCFFFF"/>
-          </a:solidFill>
-          <a:ln/>
-        </p:spPr>
-      </p:sp>
-      <p:sp>
-        <p:nvSpPr>
-          <p:cNvPr id="67" name="Text 65"/>
-          <p:cNvSpPr/>
-          <p:nvPr/>
-        </p:nvSpPr>
-        <p:spPr>
-          <a:xfrm>
-            <a:off x="1955800" y="5041900"/>
-            <a:ext cx="508000" cy="330200"/>
-          </a:xfrm>
-          <a:prstGeom prst="rect">
-            <a:avLst/>
-          </a:prstGeom>
-          <a:noFill/>
-          <a:ln/>
-        </p:spPr>
-        <p:txBody>
-          <a:bodyPr wrap="square" lIns="0" tIns="0" rIns="0" bIns="0" rtlCol="0" anchor="ctr"/>
-          <a:lstStyle/>
-          <a:p>
-            <a:pPr algn="l" indent="0" marL="0">
-              <a:buNone/>
-            </a:pPr>
-            <a:endParaRPr lang="en-US" sz="1000" dirty="0"/>
-          </a:p>
-        </p:txBody>
-      </p:sp>
-      <p:sp>
-        <p:nvSpPr>
-          <p:cNvPr id="68" name="Text 66"/>
-          <p:cNvSpPr/>
-          <p:nvPr/>
-        </p:nvSpPr>
-        <p:spPr>
-          <a:xfrm>
-            <a:off x="2311400" y="5041900"/>
-            <a:ext cx="508000" cy="330200"/>
-          </a:xfrm>
-          <a:prstGeom prst="rect">
-            <a:avLst/>
-          </a:prstGeom>
-          <a:noFill/>
-          <a:ln/>
-        </p:spPr>
-        <p:txBody>
-          <a:bodyPr wrap="square" lIns="0" tIns="0" rIns="0" bIns="0" rtlCol="0" anchor="ctr"/>
-          <a:lstStyle/>
-          <a:p>
-            <a:pPr algn="l" indent="0" marL="0">
-              <a:buNone/>
-            </a:pPr>
-            <a:r>
-              <a:rPr lang="en-US" sz="1000" i="1" dirty="0">
-                <a:solidFill>
-                  <a:srgbClr val="000000"/>
-                </a:solidFill>
-                <a:latin typeface="Arial" pitchFamily="34" charset="0"/>
-                <a:ea typeface="Arial" pitchFamily="34" charset="-122"/>
-                <a:cs typeface="Arial" pitchFamily="34" charset="-120"/>
-              </a:rPr>
-              <a:t>x</a:t>
-            </a:r>
-            <a:pPr algn="l" indent="0" marL="0">
-              <a:buNone/>
-            </a:pPr>
-            <a:r>
-              <a:rPr lang="en-US" sz="1000" i="1" baseline="-40000" dirty="0">
-                <a:solidFill>
-                  <a:srgbClr val="000000"/>
-                </a:solidFill>
-                <a:latin typeface="Arial" pitchFamily="34" charset="0"/>
-                <a:ea typeface="Arial" pitchFamily="34" charset="-122"/>
-                <a:cs typeface="Arial" pitchFamily="34" charset="-120"/>
-              </a:rPr>
-              <a:t>21</a:t>
-            </a:r>
-            <a:endParaRPr lang="en-US" sz="1000" dirty="0"/>
-          </a:p>
-        </p:txBody>
-      </p:sp>
-      <p:sp>
-        <p:nvSpPr>
-          <p:cNvPr id="69" name="Text 67"/>
-          <p:cNvSpPr/>
-          <p:nvPr/>
-        </p:nvSpPr>
-        <p:spPr>
-          <a:xfrm>
-            <a:off x="2870200" y="5041900"/>
-            <a:ext cx="508000" cy="330200"/>
-          </a:xfrm>
-          <a:prstGeom prst="rect">
-            <a:avLst/>
-          </a:prstGeom>
-          <a:noFill/>
-          <a:ln/>
-        </p:spPr>
-        <p:txBody>
-          <a:bodyPr wrap="square" lIns="0" tIns="0" rIns="0" bIns="0" rtlCol="0" anchor="ctr"/>
-          <a:lstStyle/>
-          <a:p>
-            <a:pPr algn="l" indent="0" marL="0">
-              <a:buNone/>
-            </a:pPr>
-            <a:r>
-              <a:rPr lang="en-US" sz="1000" i="1" dirty="0">
-                <a:solidFill>
-                  <a:srgbClr val="000000"/>
-                </a:solidFill>
-                <a:latin typeface="Arial" pitchFamily="34" charset="0"/>
-                <a:ea typeface="Arial" pitchFamily="34" charset="-122"/>
-                <a:cs typeface="Arial" pitchFamily="34" charset="-120"/>
-              </a:rPr>
-              <a:t>x</a:t>
-            </a:r>
-            <a:pPr algn="l" indent="0" marL="0">
-              <a:buNone/>
-            </a:pPr>
-            <a:r>
-              <a:rPr lang="en-US" sz="1000" i="1" baseline="-40000" dirty="0">
-                <a:solidFill>
-                  <a:srgbClr val="000000"/>
-                </a:solidFill>
-                <a:latin typeface="Arial" pitchFamily="34" charset="0"/>
-                <a:ea typeface="Arial" pitchFamily="34" charset="-122"/>
-                <a:cs typeface="Arial" pitchFamily="34" charset="-120"/>
-              </a:rPr>
-              <a:t>22</a:t>
-            </a:r>
-            <a:endParaRPr lang="en-US" sz="1000" dirty="0"/>
-          </a:p>
-        </p:txBody>
-      </p:sp>
-      <p:sp>
-        <p:nvSpPr>
-          <p:cNvPr id="70" name="Text 68"/>
-          <p:cNvSpPr/>
-          <p:nvPr/>
-        </p:nvSpPr>
-        <p:spPr>
-          <a:xfrm>
-            <a:off x="3429000" y="5041900"/>
-            <a:ext cx="508000" cy="330200"/>
-          </a:xfrm>
-          <a:prstGeom prst="rect">
-            <a:avLst/>
-          </a:prstGeom>
-          <a:noFill/>
-          <a:ln/>
-        </p:spPr>
-        <p:txBody>
-          <a:bodyPr wrap="square" lIns="0" tIns="0" rIns="0" bIns="0" rtlCol="0" anchor="ctr"/>
-          <a:lstStyle/>
-          <a:p>
-            <a:pPr algn="l" indent="0" marL="0">
-              <a:buNone/>
-            </a:pPr>
-            <a:r>
-              <a:rPr lang="en-US" sz="1000" i="1" dirty="0">
-                <a:solidFill>
-                  <a:srgbClr val="000000"/>
-                </a:solidFill>
-                <a:latin typeface="Arial" pitchFamily="34" charset="0"/>
-                <a:ea typeface="Arial" pitchFamily="34" charset="-122"/>
-                <a:cs typeface="Arial" pitchFamily="34" charset="-120"/>
-              </a:rPr>
-              <a:t>...</a:t>
-            </a:r>
-            <a:endParaRPr lang="en-US" sz="1000" dirty="0"/>
-          </a:p>
-        </p:txBody>
-      </p:sp>
-      <p:sp>
-        <p:nvSpPr>
-          <p:cNvPr id="71" name="Text 69"/>
-          <p:cNvSpPr/>
-          <p:nvPr/>
-        </p:nvSpPr>
-        <p:spPr>
-          <a:xfrm>
-            <a:off x="3987800" y="5041900"/>
-            <a:ext cx="508000" cy="330200"/>
-          </a:xfrm>
-          <a:prstGeom prst="rect">
-            <a:avLst/>
-          </a:prstGeom>
-          <a:noFill/>
-          <a:ln/>
-        </p:spPr>
-        <p:txBody>
-          <a:bodyPr wrap="square" lIns="0" tIns="0" rIns="0" bIns="0" rtlCol="0" anchor="ctr"/>
-          <a:lstStyle/>
-          <a:p>
-            <a:pPr algn="l" indent="0" marL="0">
-              <a:buNone/>
-            </a:pPr>
-            <a:r>
-              <a:rPr lang="en-US" sz="1000" i="1" dirty="0">
-                <a:solidFill>
-                  <a:srgbClr val="000000"/>
-                </a:solidFill>
-                <a:latin typeface="Arial" pitchFamily="34" charset="0"/>
-                <a:ea typeface="Arial" pitchFamily="34" charset="-122"/>
-                <a:cs typeface="Arial" pitchFamily="34" charset="-120"/>
-              </a:rPr>
-              <a:t>x</a:t>
-            </a:r>
-            <a:pPr algn="l" indent="0" marL="0">
-              <a:buNone/>
-            </a:pPr>
-            <a:r>
-              <a:rPr lang="en-US" sz="1000" i="1" baseline="-40000" dirty="0">
-                <a:solidFill>
-                  <a:srgbClr val="000000"/>
-                </a:solidFill>
-                <a:latin typeface="Arial" pitchFamily="34" charset="0"/>
-                <a:ea typeface="Arial" pitchFamily="34" charset="-122"/>
-                <a:cs typeface="Arial" pitchFamily="34" charset="-120"/>
-              </a:rPr>
-              <a:t>2d</a:t>
-            </a:r>
-            <a:endParaRPr lang="en-US" sz="1000" dirty="0"/>
-          </a:p>
-        </p:txBody>
-      </p:sp>
-      <p:sp>
-        <p:nvSpPr>
-          <p:cNvPr id="72" name="Text 70"/>
-          <p:cNvSpPr/>
-          <p:nvPr/>
-        </p:nvSpPr>
-        <p:spPr>
-          <a:xfrm>
-            <a:off x="1955800" y="5422900"/>
-            <a:ext cx="508000" cy="317500"/>
-          </a:xfrm>
-          <a:prstGeom prst="rect">
-            <a:avLst/>
-          </a:prstGeom>
-          <a:noFill/>
-          <a:ln/>
-        </p:spPr>
-        <p:txBody>
-          <a:bodyPr wrap="square" lIns="0" tIns="0" rIns="0" bIns="0" rtlCol="0" anchor="ctr"/>
-          <a:lstStyle/>
-          <a:p>
-            <a:pPr algn="l" indent="0" marL="0">
-              <a:buNone/>
-            </a:pPr>
-            <a:endParaRPr lang="en-US" sz="1000" dirty="0"/>
-          </a:p>
-        </p:txBody>
-      </p:sp>
-      <p:sp>
-        <p:nvSpPr>
-          <p:cNvPr id="73" name="Text 71"/>
-          <p:cNvSpPr/>
-          <p:nvPr/>
-        </p:nvSpPr>
-        <p:spPr>
-          <a:xfrm>
-            <a:off x="2311400" y="5422900"/>
-            <a:ext cx="508000" cy="317500"/>
-          </a:xfrm>
-          <a:prstGeom prst="rect">
-            <a:avLst/>
-          </a:prstGeom>
-          <a:noFill/>
-          <a:ln/>
-        </p:spPr>
-        <p:txBody>
-          <a:bodyPr wrap="square" lIns="0" tIns="0" rIns="0" bIns="0" rtlCol="0" anchor="ctr"/>
-          <a:lstStyle/>
-          <a:p>
-            <a:pPr algn="l" indent="0" marL="0">
-              <a:buNone/>
-            </a:pPr>
-            <a:r>
-              <a:rPr lang="en-US" sz="1000" i="1" dirty="0">
-                <a:solidFill>
-                  <a:srgbClr val="000000"/>
-                </a:solidFill>
-                <a:latin typeface="Arial" pitchFamily="34" charset="0"/>
-                <a:ea typeface="Arial" pitchFamily="34" charset="-122"/>
-                <a:cs typeface="Arial" pitchFamily="34" charset="-120"/>
-              </a:rPr>
-              <a:t>...</a:t>
-            </a:r>
-            <a:endParaRPr lang="en-US" sz="1000" dirty="0"/>
-          </a:p>
-        </p:txBody>
-      </p:sp>
-      <p:sp>
-        <p:nvSpPr>
-          <p:cNvPr id="74" name="Text 72"/>
-          <p:cNvSpPr/>
-          <p:nvPr/>
-        </p:nvSpPr>
-        <p:spPr>
-          <a:xfrm>
-            <a:off x="2870200" y="5422900"/>
-            <a:ext cx="508000" cy="317500"/>
-          </a:xfrm>
-          <a:prstGeom prst="rect">
-            <a:avLst/>
-          </a:prstGeom>
-          <a:noFill/>
-          <a:ln/>
-        </p:spPr>
-        <p:txBody>
-          <a:bodyPr wrap="square" lIns="0" tIns="0" rIns="0" bIns="0" rtlCol="0" anchor="ctr"/>
-          <a:lstStyle/>
-          <a:p>
-            <a:pPr algn="l" indent="0" marL="0">
-              <a:buNone/>
-            </a:pPr>
-            <a:r>
-              <a:rPr lang="en-US" sz="1000" i="1" dirty="0">
-                <a:solidFill>
-                  <a:srgbClr val="000000"/>
-                </a:solidFill>
-                <a:latin typeface="Arial" pitchFamily="34" charset="0"/>
-                <a:ea typeface="Arial" pitchFamily="34" charset="-122"/>
-                <a:cs typeface="Arial" pitchFamily="34" charset="-120"/>
-              </a:rPr>
-              <a:t>...</a:t>
-            </a:r>
-            <a:endParaRPr lang="en-US" sz="1000" dirty="0"/>
-          </a:p>
-        </p:txBody>
-      </p:sp>
-      <p:sp>
-        <p:nvSpPr>
-          <p:cNvPr id="75" name="Text 73"/>
-          <p:cNvSpPr/>
-          <p:nvPr/>
-        </p:nvSpPr>
-        <p:spPr>
-          <a:xfrm>
-            <a:off x="3429000" y="5422900"/>
-            <a:ext cx="508000" cy="317500"/>
-          </a:xfrm>
-          <a:prstGeom prst="rect">
-            <a:avLst/>
-          </a:prstGeom>
-          <a:noFill/>
-          <a:ln/>
-        </p:spPr>
-        <p:txBody>
-          <a:bodyPr wrap="square" lIns="0" tIns="0" rIns="0" bIns="0" rtlCol="0" anchor="ctr"/>
-          <a:lstStyle/>
-          <a:p>
-            <a:pPr algn="l" indent="0" marL="0">
-              <a:buNone/>
-            </a:pPr>
-            <a:r>
-              <a:rPr lang="en-US" sz="1000" i="1" dirty="0">
-                <a:solidFill>
-                  <a:srgbClr val="000000"/>
-                </a:solidFill>
-                <a:latin typeface="Arial" pitchFamily="34" charset="0"/>
-                <a:ea typeface="Arial" pitchFamily="34" charset="-122"/>
-                <a:cs typeface="Arial" pitchFamily="34" charset="-120"/>
-              </a:rPr>
-              <a:t>...</a:t>
-            </a:r>
-            <a:endParaRPr lang="en-US" sz="1000" dirty="0"/>
-          </a:p>
-        </p:txBody>
-      </p:sp>
-      <p:sp>
-        <p:nvSpPr>
-          <p:cNvPr id="76" name="Text 74"/>
-          <p:cNvSpPr/>
-          <p:nvPr/>
-        </p:nvSpPr>
-        <p:spPr>
-          <a:xfrm>
-            <a:off x="3987800" y="5422900"/>
-            <a:ext cx="508000" cy="317500"/>
-          </a:xfrm>
-          <a:prstGeom prst="rect">
-            <a:avLst/>
-          </a:prstGeom>
-          <a:noFill/>
-          <a:ln/>
-        </p:spPr>
-        <p:txBody>
-          <a:bodyPr wrap="square" lIns="0" tIns="0" rIns="0" bIns="0" rtlCol="0" anchor="ctr"/>
-          <a:lstStyle/>
-          <a:p>
-            <a:pPr algn="l" indent="0" marL="0">
-              <a:buNone/>
-            </a:pPr>
-            <a:r>
-              <a:rPr lang="en-US" sz="1000" i="1" dirty="0">
-                <a:solidFill>
-                  <a:srgbClr val="000000"/>
-                </a:solidFill>
-                <a:latin typeface="Arial" pitchFamily="34" charset="0"/>
-                <a:ea typeface="Arial" pitchFamily="34" charset="-122"/>
-                <a:cs typeface="Arial" pitchFamily="34" charset="-120"/>
-              </a:rPr>
-              <a:t>...</a:t>
-            </a:r>
-            <a:endParaRPr lang="en-US" sz="1000" dirty="0"/>
-          </a:p>
-        </p:txBody>
-      </p:sp>
-      <p:sp>
-        <p:nvSpPr>
-          <p:cNvPr id="77" name="Shape 75"/>
-          <p:cNvSpPr/>
-          <p:nvPr/>
-        </p:nvSpPr>
-        <p:spPr>
-          <a:xfrm>
-            <a:off x="1905000" y="5791200"/>
-            <a:ext cx="3581400" cy="279400"/>
-          </a:xfrm>
-          <a:prstGeom prst="rect">
-            <a:avLst/>
-          </a:prstGeom>
-          <a:solidFill>
-            <a:srgbClr val="FFC0CB"/>
-          </a:solidFill>
-          <a:ln/>
-        </p:spPr>
-      </p:sp>
-      <p:sp>
-        <p:nvSpPr>
-          <p:cNvPr id="78" name="Text 76"/>
-          <p:cNvSpPr/>
-          <p:nvPr/>
-        </p:nvSpPr>
-        <p:spPr>
-          <a:xfrm>
-            <a:off x="1955800" y="5791200"/>
-            <a:ext cx="508000" cy="279400"/>
-          </a:xfrm>
-          <a:prstGeom prst="rect">
-            <a:avLst/>
-          </a:prstGeom>
-          <a:noFill/>
-          <a:ln/>
-        </p:spPr>
-        <p:txBody>
-          <a:bodyPr wrap="square" lIns="0" tIns="0" rIns="0" bIns="0" rtlCol="0" anchor="ctr"/>
-          <a:lstStyle/>
-          <a:p>
-            <a:pPr algn="l" indent="0" marL="0">
-              <a:buNone/>
-            </a:pPr>
-            <a:endParaRPr lang="en-US" sz="1000" dirty="0"/>
-          </a:p>
-        </p:txBody>
-      </p:sp>
-      <p:sp>
-        <p:nvSpPr>
-          <p:cNvPr id="79" name="Text 77"/>
-          <p:cNvSpPr/>
-          <p:nvPr/>
-        </p:nvSpPr>
-        <p:spPr>
-          <a:xfrm>
-            <a:off x="2311400" y="5791200"/>
-            <a:ext cx="508000" cy="279400"/>
-          </a:xfrm>
-          <a:prstGeom prst="rect">
-            <a:avLst/>
-          </a:prstGeom>
-          <a:noFill/>
-          <a:ln/>
-        </p:spPr>
-        <p:txBody>
-          <a:bodyPr wrap="square" lIns="0" tIns="0" rIns="0" bIns="0" rtlCol="0" anchor="ctr"/>
-          <a:lstStyle/>
-          <a:p>
-            <a:pPr algn="l" indent="0" marL="0">
-              <a:buNone/>
-            </a:pPr>
-            <a:r>
-              <a:rPr lang="en-US" sz="1000" i="1" dirty="0">
-                <a:solidFill>
-                  <a:srgbClr val="000000"/>
-                </a:solidFill>
-                <a:latin typeface="Arial" pitchFamily="34" charset="0"/>
-                <a:ea typeface="Arial" pitchFamily="34" charset="-122"/>
-                <a:cs typeface="Arial" pitchFamily="34" charset="-120"/>
-              </a:rPr>
-              <a:t>x</a:t>
-            </a:r>
-            <a:pPr algn="l" indent="0" marL="0">
-              <a:buNone/>
-            </a:pPr>
-            <a:r>
-              <a:rPr lang="en-US" sz="1000" i="1" baseline="-40000" dirty="0">
-                <a:solidFill>
-                  <a:srgbClr val="000000"/>
-                </a:solidFill>
-                <a:latin typeface="Arial" pitchFamily="34" charset="0"/>
-                <a:ea typeface="Arial" pitchFamily="34" charset="-122"/>
-                <a:cs typeface="Arial" pitchFamily="34" charset="-120"/>
-              </a:rPr>
-              <a:t>n1</a:t>
-            </a:r>
-            <a:endParaRPr lang="en-US" sz="1000" dirty="0"/>
-          </a:p>
-        </p:txBody>
-      </p:sp>
-      <p:sp>
-        <p:nvSpPr>
-          <p:cNvPr id="80" name="Text 78"/>
-          <p:cNvSpPr/>
-          <p:nvPr/>
-        </p:nvSpPr>
-        <p:spPr>
-          <a:xfrm>
-            <a:off x="2870200" y="5791200"/>
-            <a:ext cx="508000" cy="279400"/>
-          </a:xfrm>
-          <a:prstGeom prst="rect">
-            <a:avLst/>
-          </a:prstGeom>
-          <a:noFill/>
-          <a:ln/>
-        </p:spPr>
-        <p:txBody>
-          <a:bodyPr wrap="square" lIns="0" tIns="0" rIns="0" bIns="0" rtlCol="0" anchor="ctr"/>
-          <a:lstStyle/>
-          <a:p>
-            <a:pPr algn="l" indent="0" marL="0">
-              <a:buNone/>
-            </a:pPr>
-            <a:r>
-              <a:rPr lang="en-US" sz="1000" i="1" dirty="0">
-                <a:solidFill>
-                  <a:srgbClr val="000000"/>
-                </a:solidFill>
-                <a:latin typeface="Arial" pitchFamily="34" charset="0"/>
-                <a:ea typeface="Arial" pitchFamily="34" charset="-122"/>
-                <a:cs typeface="Arial" pitchFamily="34" charset="-120"/>
-              </a:rPr>
-              <a:t>x</a:t>
-            </a:r>
-            <a:pPr algn="l" indent="0" marL="0">
-              <a:buNone/>
-            </a:pPr>
-            <a:r>
-              <a:rPr lang="en-US" sz="1000" i="1" baseline="-40000" dirty="0">
-                <a:solidFill>
-                  <a:srgbClr val="000000"/>
-                </a:solidFill>
-                <a:latin typeface="Arial" pitchFamily="34" charset="0"/>
-                <a:ea typeface="Arial" pitchFamily="34" charset="-122"/>
-                <a:cs typeface="Arial" pitchFamily="34" charset="-120"/>
-              </a:rPr>
-              <a:t>n2</a:t>
-            </a:r>
-            <a:endParaRPr lang="en-US" sz="1000" dirty="0"/>
-          </a:p>
-        </p:txBody>
-      </p:sp>
-      <p:sp>
-        <p:nvSpPr>
-          <p:cNvPr id="81" name="Text 79"/>
-          <p:cNvSpPr/>
-          <p:nvPr/>
-        </p:nvSpPr>
-        <p:spPr>
-          <a:xfrm>
-            <a:off x="3429000" y="5791200"/>
-            <a:ext cx="508000" cy="279400"/>
-          </a:xfrm>
-          <a:prstGeom prst="rect">
-            <a:avLst/>
-          </a:prstGeom>
-          <a:noFill/>
-          <a:ln/>
-        </p:spPr>
-        <p:txBody>
-          <a:bodyPr wrap="square" lIns="0" tIns="0" rIns="0" bIns="0" rtlCol="0" anchor="ctr"/>
-          <a:lstStyle/>
-          <a:p>
-            <a:pPr algn="l" indent="0" marL="0">
-              <a:buNone/>
-            </a:pPr>
-            <a:r>
-              <a:rPr lang="en-US" sz="1000" i="1" dirty="0">
-                <a:solidFill>
-                  <a:srgbClr val="000000"/>
-                </a:solidFill>
-                <a:latin typeface="Arial" pitchFamily="34" charset="0"/>
-                <a:ea typeface="Arial" pitchFamily="34" charset="-122"/>
-                <a:cs typeface="Arial" pitchFamily="34" charset="-120"/>
-              </a:rPr>
-              <a:t>...</a:t>
-            </a:r>
-            <a:endParaRPr lang="en-US" sz="1000" dirty="0"/>
-          </a:p>
-        </p:txBody>
-      </p:sp>
-      <p:sp>
-        <p:nvSpPr>
-          <p:cNvPr id="82" name="Text 80"/>
-          <p:cNvSpPr/>
-          <p:nvPr/>
-        </p:nvSpPr>
-        <p:spPr>
-          <a:xfrm>
-            <a:off x="3987800" y="5791200"/>
-            <a:ext cx="508000" cy="279400"/>
-          </a:xfrm>
-          <a:prstGeom prst="rect">
-            <a:avLst/>
-          </a:prstGeom>
-          <a:noFill/>
-          <a:ln/>
-        </p:spPr>
-        <p:txBody>
-          <a:bodyPr wrap="square" lIns="0" tIns="0" rIns="0" bIns="0" rtlCol="0" anchor="ctr"/>
-          <a:lstStyle/>
-          <a:p>
-            <a:pPr algn="l" indent="0" marL="0">
-              <a:buNone/>
-            </a:pPr>
-            <a:r>
-              <a:rPr lang="en-US" sz="1000" i="1" dirty="0">
-                <a:solidFill>
-                  <a:srgbClr val="000000"/>
-                </a:solidFill>
-                <a:latin typeface="Arial" pitchFamily="34" charset="0"/>
-                <a:ea typeface="Arial" pitchFamily="34" charset="-122"/>
-                <a:cs typeface="Arial" pitchFamily="34" charset="-120"/>
-              </a:rPr>
-              <a:t>x</a:t>
-            </a:r>
-            <a:pPr algn="l" indent="0" marL="0">
-              <a:buNone/>
-            </a:pPr>
-            <a:r>
-              <a:rPr lang="en-US" sz="1000" i="1" baseline="-40000" dirty="0">
-                <a:solidFill>
-                  <a:srgbClr val="000000"/>
-                </a:solidFill>
-                <a:latin typeface="Arial" pitchFamily="34" charset="0"/>
-                <a:ea typeface="Arial" pitchFamily="34" charset="-122"/>
-                <a:cs typeface="Arial" pitchFamily="34" charset="-120"/>
-              </a:rPr>
-              <a:t>nd</a:t>
-            </a:r>
-            <a:endParaRPr lang="en-US" sz="1000" dirty="0"/>
-          </a:p>
-        </p:txBody>
-      </p:sp>
-      <p:sp>
-        <p:nvSpPr>
-          <p:cNvPr id="83" name="Shape 81"/>
-          <p:cNvSpPr/>
-          <p:nvPr/>
-        </p:nvSpPr>
-        <p:spPr>
-          <a:xfrm>
-            <a:off x="5511800" y="4597400"/>
-            <a:ext cx="114300" cy="1549400"/>
-          </a:xfrm>
-          <a:prstGeom prst="rightBracket">
-            <a:avLst/>
-          </a:prstGeom>
-          <a:ln w="12700">
-            <a:solidFill>
-              <a:srgbClr val="808080"/>
-            </a:solidFill>
-            <a:prstDash val="solid"/>
-          </a:ln>
-        </p:spPr>
-      </p:sp>
-      <p:sp>
-        <p:nvSpPr>
-          <p:cNvPr id="84" name="Text 82"/>
-          <p:cNvSpPr/>
-          <p:nvPr/>
-        </p:nvSpPr>
-        <p:spPr>
-          <a:xfrm>
-            <a:off x="2413000" y="6019800"/>
-            <a:ext cx="1397000" cy="228600"/>
-          </a:xfrm>
-          <a:prstGeom prst="rect">
-            <a:avLst/>
-          </a:prstGeom>
-          <a:noFill/>
-          <a:ln/>
-        </p:spPr>
-        <p:txBody>
-          <a:bodyPr wrap="square" lIns="0" tIns="0" rIns="0" bIns="0" rtlCol="0" anchor="t"/>
-          <a:lstStyle/>
-          <a:p>
-            <a:pPr algn="ctr" indent="0" marL="0">
-              <a:buNone/>
-            </a:pPr>
-            <a:r>
-              <a:rPr lang="en-US" sz="1100" b="1" dirty="0">
-                <a:solidFill>
-                  <a:srgbClr val="FF0000"/>
-                </a:solidFill>
-                <a:latin typeface="Arial" pitchFamily="34" charset="0"/>
-                <a:ea typeface="Arial" pitchFamily="34" charset="-122"/>
-                <a:cs typeface="Arial" pitchFamily="34" charset="-120"/>
-              </a:rPr>
-              <a:t>N × d+1</a:t>
-            </a:r>
-            <a:endParaRPr lang="en-US" sz="1100" dirty="0"/>
-          </a:p>
-        </p:txBody>
-      </p:sp>
-      <p:sp>
-        <p:nvSpPr>
-          <p:cNvPr id="85" name="Shape 83"/>
-          <p:cNvSpPr/>
-          <p:nvPr/>
-        </p:nvSpPr>
-        <p:spPr>
-          <a:xfrm>
-            <a:off x="5816600" y="4191000"/>
-            <a:ext cx="114300" cy="1879600"/>
-          </a:xfrm>
-          <a:prstGeom prst="leftBracket">
-            <a:avLst/>
-          </a:prstGeom>
-          <a:ln w="12700">
-            <a:solidFill>
-              <a:srgbClr val="000000"/>
-            </a:solidFill>
-            <a:prstDash val="solid"/>
-          </a:ln>
-        </p:spPr>
-      </p:sp>
-      <p:sp>
-        <p:nvSpPr>
-          <p:cNvPr id="86" name="Shape 84"/>
-          <p:cNvSpPr/>
-          <p:nvPr/>
-        </p:nvSpPr>
-        <p:spPr>
-          <a:xfrm>
-            <a:off x="6527800" y="4191000"/>
-            <a:ext cx="114300" cy="1879600"/>
-          </a:xfrm>
-          <a:prstGeom prst="rightBracket">
-            <a:avLst/>
-          </a:prstGeom>
-          <a:ln w="12700">
-            <a:solidFill>
-              <a:srgbClr val="000000"/>
-            </a:solidFill>
-            <a:prstDash val="solid"/>
-          </a:ln>
-        </p:spPr>
-      </p:sp>
-      <p:sp>
-        <p:nvSpPr>
-          <p:cNvPr id="87" name="Text 85"/>
+      <p:pic>
+        <p:nvPicPr>
+          <p:cNvPr id="92" name="Image 12" descr="/home/ahmed/Projects/ai_llm_slides/videos/machine-learning/03_ridger_regression_gradient_descent/recreated_pptx/qa/slide003/parens/arc_wvec_L.png">    </p:cNvPr>
+          <p:cNvPicPr>
+            <a:picLocks noChangeAspect="1"/>
+          </p:cNvPicPr>
+          <p:nvPr/>
+        </p:nvPicPr>
+        <p:blipFill>
+          <a:blip r:embed="rId13"/>
+          <a:stretch>
+            <a:fillRect/>
+          </a:stretch>
+        </p:blipFill>
+        <p:spPr>
+          <a:xfrm>
+            <a:off x="5816600" y="4419600"/>
+            <a:ext cx="48260" cy="1651000"/>
+          </a:xfrm>
+          <a:prstGeom prst="rect">
+            <a:avLst/>
+          </a:prstGeom>
+        </p:spPr>
+      </p:pic>
+      <p:pic>
+        <p:nvPicPr>
+          <p:cNvPr id="93" name="Image 13" descr="/home/ahmed/Projects/ai_llm_slides/videos/machine-learning/03_ridger_regression_gradient_descent/recreated_pptx/qa/slide003/parens/arc_wvec_R.png">    </p:cNvPr>
+          <p:cNvPicPr>
+            <a:picLocks noChangeAspect="1"/>
+          </p:cNvPicPr>
+          <p:nvPr/>
+        </p:nvPicPr>
+        <p:blipFill>
+          <a:blip r:embed="rId14"/>
+          <a:stretch>
+            <a:fillRect/>
+          </a:stretch>
+        </p:blipFill>
+        <p:spPr>
+          <a:xfrm>
+            <a:off x="6553200" y="4419600"/>
+            <a:ext cx="48260" cy="1651000"/>
+          </a:xfrm>
+          <a:prstGeom prst="rect">
+            <a:avLst/>
+          </a:prstGeom>
+        </p:spPr>
+      </p:pic>
+      <p:sp>
+        <p:nvSpPr>
+          <p:cNvPr id="94" name="Text 78"/>
           <p:cNvSpPr/>
           <p:nvPr/>
         </p:nvSpPr>
@@ -4223,7 +4498,7 @@
             <a:r>
               <a:rPr lang="en-US" sz="1300" b="1" dirty="0">
                 <a:solidFill>
-                  <a:srgbClr val="0000FF"/>
+                  <a:srgbClr val="FF0000"/>
                 </a:solidFill>
                 <a:latin typeface="Arial" pitchFamily="34" charset="0"/>
                 <a:ea typeface="Arial" pitchFamily="34" charset="-122"/>
@@ -4237,7 +4512,7 @@
       </p:sp>
       <p:sp>
         <p:nvSpPr>
-          <p:cNvPr id="88" name="Text 86"/>
+          <p:cNvPr id="95" name="Text 79"/>
           <p:cNvSpPr/>
           <p:nvPr/>
         </p:nvSpPr>
@@ -4262,7 +4537,7 @@
             <a:r>
               <a:rPr lang="en-US" sz="1300" i="1" dirty="0">
                 <a:solidFill>
-                  <a:srgbClr val="000000"/>
+                  <a:srgbClr val="0000FF"/>
                 </a:solidFill>
                 <a:latin typeface="Arial" pitchFamily="34" charset="0"/>
                 <a:ea typeface="Arial" pitchFamily="34" charset="-122"/>
@@ -4276,7 +4551,7 @@
             <a:r>
               <a:rPr lang="en-US" sz="1300" i="1" baseline="-40000" dirty="0">
                 <a:solidFill>
-                  <a:srgbClr val="000000"/>
+                  <a:srgbClr val="0000FF"/>
                 </a:solidFill>
                 <a:latin typeface="Arial" pitchFamily="34" charset="0"/>
                 <a:ea typeface="Arial" pitchFamily="34" charset="-122"/>
@@ -4290,7 +4565,7 @@
       </p:sp>
       <p:sp>
         <p:nvSpPr>
-          <p:cNvPr id="89" name="Text 87"/>
+          <p:cNvPr id="96" name="Text 80"/>
           <p:cNvSpPr/>
           <p:nvPr/>
         </p:nvSpPr>
@@ -4315,7 +4590,7 @@
             <a:r>
               <a:rPr lang="en-US" sz="1300" i="1" dirty="0">
                 <a:solidFill>
-                  <a:srgbClr val="000000"/>
+                  <a:srgbClr val="0000FF"/>
                 </a:solidFill>
                 <a:latin typeface="Arial" pitchFamily="34" charset="0"/>
                 <a:ea typeface="Arial" pitchFamily="34" charset="-122"/>
@@ -4329,7 +4604,7 @@
             <a:r>
               <a:rPr lang="en-US" sz="1300" i="1" baseline="-40000" dirty="0">
                 <a:solidFill>
-                  <a:srgbClr val="000000"/>
+                  <a:srgbClr val="0000FF"/>
                 </a:solidFill>
                 <a:latin typeface="Arial" pitchFamily="34" charset="0"/>
                 <a:ea typeface="Arial" pitchFamily="34" charset="-122"/>
@@ -4343,7 +4618,7 @@
       </p:sp>
       <p:sp>
         <p:nvSpPr>
-          <p:cNvPr id="90" name="Text 88"/>
+          <p:cNvPr id="97" name="Text 81"/>
           <p:cNvSpPr/>
           <p:nvPr/>
         </p:nvSpPr>
@@ -4382,7 +4657,7 @@
       </p:sp>
       <p:sp>
         <p:nvSpPr>
-          <p:cNvPr id="91" name="Text 89"/>
+          <p:cNvPr id="98" name="Text 82"/>
           <p:cNvSpPr/>
           <p:nvPr/>
         </p:nvSpPr>
@@ -4407,7 +4682,7 @@
             <a:r>
               <a:rPr lang="en-US" sz="1300" i="1" dirty="0">
                 <a:solidFill>
-                  <a:srgbClr val="000000"/>
+                  <a:srgbClr val="0000FF"/>
                 </a:solidFill>
                 <a:latin typeface="Arial" pitchFamily="34" charset="0"/>
                 <a:ea typeface="Arial" pitchFamily="34" charset="-122"/>
@@ -4421,7 +4696,7 @@
             <a:r>
               <a:rPr lang="en-US" sz="1300" i="1" baseline="-40000" dirty="0">
                 <a:solidFill>
-                  <a:srgbClr val="000000"/>
+                  <a:srgbClr val="0000FF"/>
                 </a:solidFill>
                 <a:latin typeface="Arial" pitchFamily="34" charset="0"/>
                 <a:ea typeface="Arial" pitchFamily="34" charset="-122"/>
@@ -4435,7 +4710,7 @@
       </p:sp>
       <p:sp>
         <p:nvSpPr>
-          <p:cNvPr id="92" name="Text 90"/>
+          <p:cNvPr id="99" name="Text 83"/>
           <p:cNvSpPr/>
           <p:nvPr/>
         </p:nvSpPr>
@@ -4460,7 +4735,7 @@
             <a:r>
               <a:rPr lang="en-US" sz="1100" b="1" dirty="0">
                 <a:solidFill>
-                  <a:srgbClr val="FF0000"/>
+                  <a:srgbClr val="4D429E"/>
                 </a:solidFill>
                 <a:latin typeface="Arial" pitchFamily="34" charset="0"/>
                 <a:ea typeface="Arial" pitchFamily="34" charset="-122"/>
@@ -4474,14 +4749,14 @@
       </p:sp>
       <p:sp>
         <p:nvSpPr>
-          <p:cNvPr id="93" name="Shape 91"/>
-          <p:cNvSpPr/>
-          <p:nvPr/>
-        </p:nvSpPr>
-        <p:spPr>
-          <a:xfrm>
-            <a:off x="6756400" y="4978400"/>
-            <a:ext cx="508000" cy="0"/>
+          <p:cNvPr id="100" name="Shape 84"/>
+          <p:cNvSpPr/>
+          <p:nvPr/>
+        </p:nvSpPr>
+        <p:spPr>
+          <a:xfrm>
+            <a:off x="6896100" y="5181600"/>
+            <a:ext cx="431800" cy="0"/>
           </a:xfrm>
           <a:prstGeom prst="line">
             <a:avLst/>
@@ -4498,14 +4773,14 @@
       </p:sp>
       <p:sp>
         <p:nvSpPr>
-          <p:cNvPr id="94" name="Shape 92"/>
-          <p:cNvSpPr/>
-          <p:nvPr/>
-        </p:nvSpPr>
-        <p:spPr>
-          <a:xfrm>
-            <a:off x="7264400" y="4102100"/>
-            <a:ext cx="2286000" cy="2463800"/>
+          <p:cNvPr id="101" name="Shape 85"/>
+          <p:cNvSpPr/>
+          <p:nvPr/>
+        </p:nvSpPr>
+        <p:spPr>
+          <a:xfrm>
+            <a:off x="7429500" y="4102100"/>
+            <a:ext cx="3822700" cy="2463800"/>
           </a:xfrm>
           <a:prstGeom prst="rect">
             <a:avLst/>
@@ -4523,14 +4798,14 @@
       </p:sp>
       <p:sp>
         <p:nvSpPr>
-          <p:cNvPr id="95" name="Text 93"/>
-          <p:cNvSpPr/>
-          <p:nvPr/>
-        </p:nvSpPr>
-        <p:spPr>
-          <a:xfrm>
-            <a:off x="7289800" y="4635500"/>
-            <a:ext cx="2235200" cy="381000"/>
+          <p:cNvPr id="102" name="Text 86"/>
+          <p:cNvSpPr/>
+          <p:nvPr/>
+        </p:nvSpPr>
+        <p:spPr>
+          <a:xfrm>
+            <a:off x="7683500" y="4521200"/>
+            <a:ext cx="3314700" cy="381000"/>
           </a:xfrm>
           <a:prstGeom prst="rect">
             <a:avLst/>
@@ -4576,7 +4851,7 @@
             <a:r>
               <a:rPr lang="en-US" sz="1600" b="1" u="sng" dirty="0">
                 <a:solidFill>
-                  <a:srgbClr val="000000"/>
+                  <a:srgbClr val="0000FF"/>
                 </a:solidFill>
                 <a:latin typeface="Arial" pitchFamily="34" charset="0"/>
                 <a:ea typeface="Arial" pitchFamily="34" charset="-122"/>
@@ -4604,7 +4879,7 @@
             <a:r>
               <a:rPr lang="en-US" sz="1600" b="1" u="sng" dirty="0">
                 <a:solidFill>
-                  <a:srgbClr val="000000"/>
+                  <a:srgbClr val="FF0000"/>
                 </a:solidFill>
                 <a:latin typeface="Arial" pitchFamily="34" charset="0"/>
                 <a:ea typeface="Arial" pitchFamily="34" charset="-122"/>
@@ -4618,14 +4893,14 @@
       </p:sp>
       <p:sp>
         <p:nvSpPr>
-          <p:cNvPr id="96" name="Text 94"/>
-          <p:cNvSpPr/>
-          <p:nvPr/>
-        </p:nvSpPr>
-        <p:spPr>
-          <a:xfrm>
-            <a:off x="7416800" y="5041900"/>
-            <a:ext cx="1981200" cy="279400"/>
+          <p:cNvPr id="103" name="Text 87"/>
+          <p:cNvSpPr/>
+          <p:nvPr/>
+        </p:nvSpPr>
+        <p:spPr>
+          <a:xfrm>
+            <a:off x="7683500" y="5054600"/>
+            <a:ext cx="3314700" cy="279400"/>
           </a:xfrm>
           <a:prstGeom prst="rect">
             <a:avLst/>
@@ -4657,7 +4932,7 @@
             <a:r>
               <a:rPr lang="en-US" sz="1300" i="1" u="sng" dirty="0">
                 <a:solidFill>
-                  <a:srgbClr val="000000"/>
+                  <a:srgbClr val="0000FF"/>
                 </a:solidFill>
                 <a:latin typeface="Arial" pitchFamily="34" charset="0"/>
                 <a:ea typeface="Arial" pitchFamily="34" charset="-122"/>
@@ -4671,7 +4946,7 @@
             <a:r>
               <a:rPr lang="en-US" sz="1300" i="1" baseline="-40000" dirty="0">
                 <a:solidFill>
-                  <a:srgbClr val="000000"/>
+                  <a:srgbClr val="0000FF"/>
                 </a:solidFill>
                 <a:latin typeface="Arial" pitchFamily="34" charset="0"/>
                 <a:ea typeface="Arial" pitchFamily="34" charset="-122"/>
@@ -4683,7 +4958,7 @@
               <a:buNone/>
             </a:pPr>
             <a:r>
-              <a:rPr lang="en-US" sz="1300" i="1" dirty="0">
+              <a:rPr lang="en-US" sz="1300" b="1" dirty="0">
                 <a:solidFill>
                   <a:srgbClr val="000000"/>
                 </a:solidFill>
@@ -4699,14 +4974,14 @@
       </p:sp>
       <p:sp>
         <p:nvSpPr>
-          <p:cNvPr id="97" name="Text 95"/>
-          <p:cNvSpPr/>
-          <p:nvPr/>
-        </p:nvSpPr>
-        <p:spPr>
-          <a:xfrm>
-            <a:off x="7416800" y="5626100"/>
-            <a:ext cx="1981200" cy="279400"/>
+          <p:cNvPr id="104" name="Text 88"/>
+          <p:cNvSpPr/>
+          <p:nvPr/>
+        </p:nvSpPr>
+        <p:spPr>
+          <a:xfrm>
+            <a:off x="8483600" y="5664200"/>
+            <a:ext cx="2514600" cy="279400"/>
           </a:xfrm>
           <a:prstGeom prst="rect">
             <a:avLst/>
@@ -4724,7 +4999,7 @@
             <a:r>
               <a:rPr lang="en-US" sz="1300" i="1" u="sng" dirty="0">
                 <a:solidFill>
-                  <a:srgbClr val="000000"/>
+                  <a:srgbClr val="FF0000"/>
                 </a:solidFill>
                 <a:latin typeface="Arial" pitchFamily="34" charset="0"/>
                 <a:ea typeface="Arial" pitchFamily="34" charset="-122"/>
@@ -4738,7 +5013,7 @@
             <a:r>
               <a:rPr lang="en-US" sz="1300" i="1" baseline="-40000" dirty="0">
                 <a:solidFill>
-                  <a:srgbClr val="000000"/>
+                  <a:srgbClr val="FF0000"/>
                 </a:solidFill>
                 <a:latin typeface="Arial" pitchFamily="34" charset="0"/>
                 <a:ea typeface="Arial" pitchFamily="34" charset="-122"/>
@@ -4750,7 +5025,7 @@
               <a:buNone/>
             </a:pPr>
             <a:r>
-              <a:rPr lang="en-US" sz="1300" i="1" dirty="0">
+              <a:rPr lang="en-US" sz="1300" b="1" dirty="0">
                 <a:solidFill>
                   <a:srgbClr val="000000"/>
                 </a:solidFill>

</xml_diff>